<commit_message>
Add McKinsey style optimization loop v0-v7 (43→97/100)
Unified evaluator (Patronus gate + Gemini scoring), 7 iterations
of skill optimization with 3 diverse test prompts. Final v7 skill
achieves 92-97/100 Gemini score with horizontal-only table borders,
column tints, and proper McKinsey structural elements.

Co-Authored-By: Claude Opus 4.6 <noreply@anthropic.com>
</commit_message>
<xml_diff>
--- a/output/slide_v5.pptx
+++ b/output/slide_v5.pptx
@@ -10,8 +10,8 @@
   <p:notesMasterIdLst>
     <p:notesMasterId r:id="rId3"/>
   </p:notesMasterIdLst>
-  <p:sldSz cx="12192000" cy="6858000"/>
-  <p:notesSz cx="6858000" cy="12192000"/>
+  <p:sldSz cx="9144000" cy="5143500"/>
+  <p:notesSz cx="5143500" cy="9144000"/>
   <p:defaultTextStyle>
     <a:lvl1pPr marL="0" algn="l" defTabSz="914400" rtl="0" eaLnBrk="1" latinLnBrk="0" hangingPunct="1">
       <a:defRPr sz="1800" kern="1200">
@@ -883,8 +883,8 @@
         </p:nvSpPr>
         <p:spPr>
           <a:xfrm>
-            <a:off x="457200" y="274320"/>
-            <a:ext cx="11274552" cy="777240"/>
+            <a:off x="457200" y="182880"/>
+            <a:ext cx="8229600" cy="594360"/>
           </a:xfrm>
           <a:prstGeom prst="rect">
             <a:avLst/>
@@ -893,14 +893,17 @@
           <a:ln/>
         </p:spPr>
         <p:txBody>
-          <a:bodyPr wrap="square" lIns="0" tIns="0" rIns="0" bIns="0" rtlCol="0" anchor="t"/>
+          <a:bodyPr wrap="square" lIns="0" tIns="0" rIns="0" bIns="0" rtlCol="0" anchor="ctr"/>
           <a:lstStyle/>
           <a:p>
             <a:pPr indent="0" marL="0">
+              <a:lnSpc>
+                <a:spcPct val="115000"/>
+              </a:lnSpc>
               <a:buNone/>
             </a:pPr>
             <a:r>
-              <a:rPr lang="en-US" sz="2200" b="1" dirty="0">
+              <a:rPr lang="en-US" sz="1600" b="1" dirty="0">
                 <a:solidFill>
                   <a:srgbClr val="000000"/>
                 </a:solidFill>
@@ -908,50 +911,34 @@
                 <a:ea typeface="Georgia" pitchFamily="34" charset="-122"/>
                 <a:cs typeface="Georgia" pitchFamily="34" charset="-120"/>
               </a:rPr>
-              <a:t>The Netherlands aims to become Europe's green hydrogen hub, scaling from 500 MW to 3–4 GW by 2030</a:t>
+              <a:t>1.1/ Blue and Green hydrogen are two low-carbon production methods of H2 with the highest future potential</a:t>
             </a:r>
-            <a:endParaRPr lang="en-US" sz="2200" dirty="0"/>
+            <a:endParaRPr lang="en-US" sz="1600" dirty="0"/>
           </a:p>
         </p:txBody>
       </p:sp>
       <p:sp>
         <p:nvSpPr>
-          <p:cNvPr id="3" name="Text 1"/>
+          <p:cNvPr id="3" name="Shape 1"/>
           <p:cNvSpPr/>
           <p:nvPr/>
         </p:nvSpPr>
         <p:spPr>
           <a:xfrm>
-            <a:off x="457200" y="1097280"/>
-            <a:ext cx="11274552" cy="228600"/>
+            <a:off x="457200" y="914400"/>
+            <a:ext cx="8229600" cy="0"/>
           </a:xfrm>
-          <a:prstGeom prst="rect">
+          <a:prstGeom prst="line">
             <a:avLst/>
           </a:prstGeom>
           <a:noFill/>
-          <a:ln/>
+          <a:ln w="12700">
+            <a:solidFill>
+              <a:srgbClr val="333333"/>
+            </a:solidFill>
+            <a:prstDash val="solid"/>
+          </a:ln>
         </p:spPr>
-        <p:txBody>
-          <a:bodyPr wrap="square" lIns="0" tIns="0" rIns="0" bIns="0" rtlCol="0" anchor="t"/>
-          <a:lstStyle/>
-          <a:p>
-            <a:pPr indent="0" marL="0">
-              <a:buNone/>
-            </a:pPr>
-            <a:r>
-              <a:rPr lang="en-US" sz="1000" dirty="0">
-                <a:solidFill>
-                  <a:srgbClr val="888888"/>
-                </a:solidFill>
-                <a:latin typeface="Calibri" pitchFamily="34" charset="0"/>
-                <a:ea typeface="Calibri" pitchFamily="34" charset="-122"/>
-                <a:cs typeface="Calibri" pitchFamily="34" charset="-120"/>
-              </a:rPr>
-              <a:t>Dutch National Hydrogen Strategy timeline and key capacity milestones (2020–2035)</a:t>
-            </a:r>
-            <a:endParaRPr lang="en-US" sz="1000" dirty="0"/>
-          </a:p>
-        </p:txBody>
       </p:sp>
       <p:sp>
         <p:nvSpPr>
@@ -961,16 +948,16 @@
         </p:nvSpPr>
         <p:spPr>
           <a:xfrm>
-            <a:off x="457200" y="1325880"/>
-            <a:ext cx="11274552" cy="0"/>
+            <a:off x="457200" y="1143000"/>
+            <a:ext cx="8229600" cy="0"/>
           </a:xfrm>
           <a:prstGeom prst="line">
             <a:avLst/>
           </a:prstGeom>
           <a:noFill/>
-          <a:ln w="9525">
+          <a:ln w="25400">
             <a:solidFill>
-              <a:srgbClr val="333333"/>
+              <a:srgbClr val="1B3A5C"/>
             </a:solidFill>
             <a:prstDash val="solid"/>
           </a:ln>
@@ -978,80 +965,14 @@
       </p:sp>
       <p:sp>
         <p:nvSpPr>
-          <p:cNvPr id="5" name="Shape 3"/>
+          <p:cNvPr id="5" name="Text 3"/>
           <p:cNvSpPr/>
           <p:nvPr/>
         </p:nvSpPr>
         <p:spPr>
           <a:xfrm>
-            <a:off x="914400" y="2286000"/>
-            <a:ext cx="10058400" cy="0"/>
-          </a:xfrm>
-          <a:prstGeom prst="line">
-            <a:avLst/>
-          </a:prstGeom>
-          <a:noFill/>
-          <a:ln w="25400">
-            <a:solidFill>
-              <a:srgbClr val="0C2340"/>
-            </a:solidFill>
-            <a:prstDash val="solid"/>
-          </a:ln>
-        </p:spPr>
-      </p:sp>
-      <p:sp>
-        <p:nvSpPr>
-          <p:cNvPr id="6" name="Shape 4"/>
-          <p:cNvSpPr/>
-          <p:nvPr/>
-        </p:nvSpPr>
-        <p:spPr>
-          <a:xfrm>
-            <a:off x="914400" y="2011680"/>
-            <a:ext cx="0" cy="274320"/>
-          </a:xfrm>
-          <a:prstGeom prst="line">
-            <a:avLst/>
-          </a:prstGeom>
-          <a:noFill/>
-          <a:ln w="12700">
-            <a:solidFill>
-              <a:srgbClr val="0C2340"/>
-            </a:solidFill>
-            <a:prstDash val="solid"/>
-          </a:ln>
-        </p:spPr>
-      </p:sp>
-      <p:sp>
-        <p:nvSpPr>
-          <p:cNvPr id="7" name="Shape 5"/>
-          <p:cNvSpPr/>
-          <p:nvPr/>
-        </p:nvSpPr>
-        <p:spPr>
-          <a:xfrm>
-            <a:off x="795528" y="2167128"/>
-            <a:ext cx="237744" cy="237744"/>
-          </a:xfrm>
-          <a:prstGeom prst="ellipse">
-            <a:avLst/>
-          </a:prstGeom>
-          <a:solidFill>
-            <a:srgbClr val="0C2340"/>
-          </a:solidFill>
-          <a:ln/>
-        </p:spPr>
-      </p:sp>
-      <p:sp>
-        <p:nvSpPr>
-          <p:cNvPr id="8" name="Text 6"/>
-          <p:cNvSpPr/>
-          <p:nvPr/>
-        </p:nvSpPr>
-        <p:spPr>
-          <a:xfrm>
-            <a:off x="795528" y="2167128"/>
-            <a:ext cx="237744" cy="237744"/>
+            <a:off x="3383280" y="960120"/>
+            <a:ext cx="4572000" cy="182880"/>
           </a:xfrm>
           <a:prstGeom prst="rect">
             <a:avLst/>
@@ -1067,129 +988,30 @@
               <a:buNone/>
             </a:pPr>
             <a:r>
-              <a:rPr lang="en-US" sz="750" b="1" dirty="0">
+              <a:rPr lang="en-US" sz="900" b="1" dirty="0">
                 <a:solidFill>
-                  <a:srgbClr val="FFFFFF"/>
+                  <a:srgbClr val="333333"/>
                 </a:solidFill>
                 <a:latin typeface="Calibri" pitchFamily="34" charset="0"/>
                 <a:ea typeface="Calibri" pitchFamily="34" charset="-122"/>
                 <a:cs typeface="Calibri" pitchFamily="34" charset="-120"/>
               </a:rPr>
-              <a:t>2020</a:t>
+              <a:t>Low-carbon H2</a:t>
             </a:r>
-            <a:endParaRPr lang="en-US" sz="750" dirty="0"/>
+            <a:endParaRPr lang="en-US" sz="900" dirty="0"/>
           </a:p>
         </p:txBody>
       </p:sp>
       <p:sp>
         <p:nvSpPr>
-          <p:cNvPr id="9" name="Text 7"/>
+          <p:cNvPr id="6" name="Text 4"/>
           <p:cNvSpPr/>
           <p:nvPr/>
         </p:nvSpPr>
         <p:spPr>
           <a:xfrm>
-            <a:off x="182880" y="1508760"/>
-            <a:ext cx="1463040" cy="457200"/>
-          </a:xfrm>
-          <a:prstGeom prst="rect">
-            <a:avLst/>
-          </a:prstGeom>
-          <a:noFill/>
-          <a:ln/>
-        </p:spPr>
-        <p:txBody>
-          <a:bodyPr wrap="square" lIns="0" tIns="0" rIns="0" bIns="0" rtlCol="0" anchor="b"/>
-          <a:lstStyle/>
-          <a:p>
-            <a:pPr algn="ctr" indent="0" marL="0">
-              <a:buNone/>
-            </a:pPr>
-            <a:r>
-              <a:rPr lang="en-US" sz="850" dirty="0">
-                <a:solidFill>
-                  <a:srgbClr val="404040"/>
-                </a:solidFill>
-                <a:latin typeface="Calibri" pitchFamily="34" charset="0"/>
-                <a:ea typeface="Calibri" pitchFamily="34" charset="-122"/>
-                <a:cs typeface="Calibri" pitchFamily="34" charset="-120"/>
-              </a:rPr>
-              <a:t>National Hydrogen</a:t>
-            </a:r>
-            <a:endParaRPr lang="en-US" sz="850" dirty="0"/>
-          </a:p>
-          <a:p>
-            <a:pPr algn="ctr" indent="0" marL="0">
-              <a:buNone/>
-            </a:pPr>
-            <a:r>
-              <a:rPr lang="en-US" sz="850" dirty="0">
-                <a:solidFill>
-                  <a:srgbClr val="404040"/>
-                </a:solidFill>
-                <a:latin typeface="Calibri" pitchFamily="34" charset="0"/>
-                <a:ea typeface="Calibri" pitchFamily="34" charset="-122"/>
-                <a:cs typeface="Calibri" pitchFamily="34" charset="-120"/>
-              </a:rPr>
-              <a:t>Strategy published</a:t>
-            </a:r>
-            <a:endParaRPr lang="en-US" sz="850" dirty="0"/>
-          </a:p>
-        </p:txBody>
-      </p:sp>
-      <p:sp>
-        <p:nvSpPr>
-          <p:cNvPr id="10" name="Shape 8"/>
-          <p:cNvSpPr/>
-          <p:nvPr/>
-        </p:nvSpPr>
-        <p:spPr>
-          <a:xfrm>
-            <a:off x="2926080" y="2286000"/>
-            <a:ext cx="0" cy="274320"/>
-          </a:xfrm>
-          <a:prstGeom prst="line">
-            <a:avLst/>
-          </a:prstGeom>
-          <a:noFill/>
-          <a:ln w="12700">
-            <a:solidFill>
-              <a:srgbClr val="0C2340"/>
-            </a:solidFill>
-            <a:prstDash val="solid"/>
-          </a:ln>
-        </p:spPr>
-      </p:sp>
-      <p:sp>
-        <p:nvSpPr>
-          <p:cNvPr id="11" name="Shape 9"/>
-          <p:cNvSpPr/>
-          <p:nvPr/>
-        </p:nvSpPr>
-        <p:spPr>
-          <a:xfrm>
-            <a:off x="2807208" y="2167128"/>
-            <a:ext cx="237744" cy="237744"/>
-          </a:xfrm>
-          <a:prstGeom prst="ellipse">
-            <a:avLst/>
-          </a:prstGeom>
-          <a:solidFill>
-            <a:srgbClr val="0C2340"/>
-          </a:solidFill>
-          <a:ln/>
-        </p:spPr>
-      </p:sp>
-      <p:sp>
-        <p:nvSpPr>
-          <p:cNvPr id="12" name="Text 10"/>
-          <p:cNvSpPr/>
-          <p:nvPr/>
-        </p:nvSpPr>
-        <p:spPr>
-          <a:xfrm>
-            <a:off x="2807208" y="2167128"/>
-            <a:ext cx="237744" cy="237744"/>
+            <a:off x="6858000" y="960120"/>
+            <a:ext cx="1828800" cy="182880"/>
           </a:xfrm>
           <a:prstGeom prst="rect">
             <a:avLst/>
@@ -1201,629 +1023,38 @@
           <a:bodyPr wrap="square" lIns="0" tIns="0" rIns="0" bIns="0" rtlCol="0" anchor="ctr"/>
           <a:lstStyle/>
           <a:p>
-            <a:pPr algn="ctr" indent="0" marL="0">
+            <a:pPr indent="0" marL="0">
               <a:buNone/>
             </a:pPr>
             <a:r>
-              <a:rPr lang="en-US" sz="750" b="1" dirty="0">
+              <a:rPr lang="en-US" sz="650" dirty="0">
                 <a:solidFill>
-                  <a:srgbClr val="FFFFFF"/>
+                  <a:srgbClr val="333333"/>
                 </a:solidFill>
                 <a:latin typeface="Calibri" pitchFamily="34" charset="0"/>
                 <a:ea typeface="Calibri" pitchFamily="34" charset="-122"/>
                 <a:cs typeface="Calibri" pitchFamily="34" charset="-120"/>
               </a:rPr>
-              <a:t>2022</a:t>
+              <a:t>X    CO2 emissions</a:t>
             </a:r>
-            <a:endParaRPr lang="en-US" sz="750" dirty="0"/>
+            <a:endParaRPr lang="en-US" sz="650" dirty="0"/>
           </a:p>
-        </p:txBody>
-      </p:sp>
-      <p:sp>
-        <p:nvSpPr>
-          <p:cNvPr id="13" name="Text 11"/>
-          <p:cNvSpPr/>
-          <p:nvPr/>
-        </p:nvSpPr>
-        <p:spPr>
-          <a:xfrm>
-            <a:off x="2194560" y="2606040"/>
-            <a:ext cx="1463040" cy="457200"/>
-          </a:xfrm>
-          <a:prstGeom prst="rect">
-            <a:avLst/>
-          </a:prstGeom>
-          <a:noFill/>
-          <a:ln/>
-        </p:spPr>
-        <p:txBody>
-          <a:bodyPr wrap="square" lIns="0" tIns="0" rIns="0" bIns="0" rtlCol="0" anchor="t"/>
-          <a:lstStyle/>
           <a:p>
-            <a:pPr algn="ctr" indent="0" marL="0">
+            <a:pPr indent="0" marL="0">
               <a:buNone/>
             </a:pPr>
             <a:r>
-              <a:rPr lang="en-US" sz="850" dirty="0">
+              <a:rPr lang="en-US" sz="650" dirty="0">
                 <a:solidFill>
-                  <a:srgbClr val="404040"/>
+                  <a:srgbClr val="333333"/>
                 </a:solidFill>
                 <a:latin typeface="Calibri" pitchFamily="34" charset="0"/>
                 <a:ea typeface="Calibri" pitchFamily="34" charset="-122"/>
                 <a:cs typeface="Calibri" pitchFamily="34" charset="-120"/>
               </a:rPr>
-              <a:t>REPowerEU plan</a:t>
+              <a:t>      kg CO2 per kgH2 produced</a:t>
             </a:r>
-            <a:endParaRPr lang="en-US" sz="850" dirty="0"/>
-          </a:p>
-          <a:p>
-            <a:pPr algn="ctr" indent="0" marL="0">
-              <a:buNone/>
-            </a:pPr>
-            <a:r>
-              <a:rPr lang="en-US" sz="850" dirty="0">
-                <a:solidFill>
-                  <a:srgbClr val="404040"/>
-                </a:solidFill>
-                <a:latin typeface="Calibri" pitchFamily="34" charset="0"/>
-                <a:ea typeface="Calibri" pitchFamily="34" charset="-122"/>
-                <a:cs typeface="Calibri" pitchFamily="34" charset="-120"/>
-              </a:rPr>
-              <a:t>accelerates ambitions</a:t>
-            </a:r>
-            <a:endParaRPr lang="en-US" sz="850" dirty="0"/>
-          </a:p>
-        </p:txBody>
-      </p:sp>
-      <p:sp>
-        <p:nvSpPr>
-          <p:cNvPr id="14" name="Shape 12"/>
-          <p:cNvSpPr/>
-          <p:nvPr/>
-        </p:nvSpPr>
-        <p:spPr>
-          <a:xfrm>
-            <a:off x="4937760" y="2011680"/>
-            <a:ext cx="0" cy="274320"/>
-          </a:xfrm>
-          <a:prstGeom prst="line">
-            <a:avLst/>
-          </a:prstGeom>
-          <a:noFill/>
-          <a:ln w="12700">
-            <a:solidFill>
-              <a:srgbClr val="0C2340"/>
-            </a:solidFill>
-            <a:prstDash val="solid"/>
-          </a:ln>
-        </p:spPr>
-      </p:sp>
-      <p:sp>
-        <p:nvSpPr>
-          <p:cNvPr id="15" name="Shape 13"/>
-          <p:cNvSpPr/>
-          <p:nvPr/>
-        </p:nvSpPr>
-        <p:spPr>
-          <a:xfrm>
-            <a:off x="4818888" y="2167128"/>
-            <a:ext cx="237744" cy="237744"/>
-          </a:xfrm>
-          <a:prstGeom prst="ellipse">
-            <a:avLst/>
-          </a:prstGeom>
-          <a:solidFill>
-            <a:srgbClr val="0C2340"/>
-          </a:solidFill>
-          <a:ln/>
-        </p:spPr>
-      </p:sp>
-      <p:sp>
-        <p:nvSpPr>
-          <p:cNvPr id="16" name="Text 14"/>
-          <p:cNvSpPr/>
-          <p:nvPr/>
-        </p:nvSpPr>
-        <p:spPr>
-          <a:xfrm>
-            <a:off x="4818888" y="2167128"/>
-            <a:ext cx="237744" cy="237744"/>
-          </a:xfrm>
-          <a:prstGeom prst="rect">
-            <a:avLst/>
-          </a:prstGeom>
-          <a:noFill/>
-          <a:ln/>
-        </p:spPr>
-        <p:txBody>
-          <a:bodyPr wrap="square" lIns="0" tIns="0" rIns="0" bIns="0" rtlCol="0" anchor="ctr"/>
-          <a:lstStyle/>
-          <a:p>
-            <a:pPr algn="ctr" indent="0" marL="0">
-              <a:buNone/>
-            </a:pPr>
-            <a:r>
-              <a:rPr lang="en-US" sz="750" b="1" dirty="0">
-                <a:solidFill>
-                  <a:srgbClr val="FFFFFF"/>
-                </a:solidFill>
-                <a:latin typeface="Calibri" pitchFamily="34" charset="0"/>
-                <a:ea typeface="Calibri" pitchFamily="34" charset="-122"/>
-                <a:cs typeface="Calibri" pitchFamily="34" charset="-120"/>
-              </a:rPr>
-              <a:t>2025</a:t>
-            </a:r>
-            <a:endParaRPr lang="en-US" sz="750" dirty="0"/>
-          </a:p>
-        </p:txBody>
-      </p:sp>
-      <p:sp>
-        <p:nvSpPr>
-          <p:cNvPr id="17" name="Text 15"/>
-          <p:cNvSpPr/>
-          <p:nvPr/>
-        </p:nvSpPr>
-        <p:spPr>
-          <a:xfrm>
-            <a:off x="4206240" y="1508760"/>
-            <a:ext cx="1463040" cy="457200"/>
-          </a:xfrm>
-          <a:prstGeom prst="rect">
-            <a:avLst/>
-          </a:prstGeom>
-          <a:noFill/>
-          <a:ln/>
-        </p:spPr>
-        <p:txBody>
-          <a:bodyPr wrap="square" lIns="0" tIns="0" rIns="0" bIns="0" rtlCol="0" anchor="b"/>
-          <a:lstStyle/>
-          <a:p>
-            <a:pPr algn="ctr" indent="0" marL="0">
-              <a:buNone/>
-            </a:pPr>
-            <a:r>
-              <a:rPr lang="en-US" sz="850" dirty="0">
-                <a:solidFill>
-                  <a:srgbClr val="404040"/>
-                </a:solidFill>
-                <a:latin typeface="Calibri" pitchFamily="34" charset="0"/>
-                <a:ea typeface="Calibri" pitchFamily="34" charset="-122"/>
-                <a:cs typeface="Calibri" pitchFamily="34" charset="-120"/>
-              </a:rPr>
-              <a:t>First green H2</a:t>
-            </a:r>
-            <a:endParaRPr lang="en-US" sz="850" dirty="0"/>
-          </a:p>
-          <a:p>
-            <a:pPr algn="ctr" indent="0" marL="0">
-              <a:buNone/>
-            </a:pPr>
-            <a:r>
-              <a:rPr lang="en-US" sz="850" dirty="0">
-                <a:solidFill>
-                  <a:srgbClr val="404040"/>
-                </a:solidFill>
-                <a:latin typeface="Calibri" pitchFamily="34" charset="0"/>
-                <a:ea typeface="Calibri" pitchFamily="34" charset="-122"/>
-                <a:cs typeface="Calibri" pitchFamily="34" charset="-120"/>
-              </a:rPr>
-              <a:t>hubs operational</a:t>
-            </a:r>
-            <a:endParaRPr lang="en-US" sz="850" dirty="0"/>
-          </a:p>
-        </p:txBody>
-      </p:sp>
-      <p:sp>
-        <p:nvSpPr>
-          <p:cNvPr id="18" name="Shape 16"/>
-          <p:cNvSpPr/>
-          <p:nvPr/>
-        </p:nvSpPr>
-        <p:spPr>
-          <a:xfrm>
-            <a:off x="6949440" y="2286000"/>
-            <a:ext cx="0" cy="274320"/>
-          </a:xfrm>
-          <a:prstGeom prst="line">
-            <a:avLst/>
-          </a:prstGeom>
-          <a:noFill/>
-          <a:ln w="12700">
-            <a:solidFill>
-              <a:srgbClr val="0C2340"/>
-            </a:solidFill>
-            <a:prstDash val="solid"/>
-          </a:ln>
-        </p:spPr>
-      </p:sp>
-      <p:sp>
-        <p:nvSpPr>
-          <p:cNvPr id="19" name="Shape 17"/>
-          <p:cNvSpPr/>
-          <p:nvPr/>
-        </p:nvSpPr>
-        <p:spPr>
-          <a:xfrm>
-            <a:off x="6830568" y="2167128"/>
-            <a:ext cx="237744" cy="237744"/>
-          </a:xfrm>
-          <a:prstGeom prst="ellipse">
-            <a:avLst/>
-          </a:prstGeom>
-          <a:solidFill>
-            <a:srgbClr val="0C2340"/>
-          </a:solidFill>
-          <a:ln/>
-        </p:spPr>
-      </p:sp>
-      <p:sp>
-        <p:nvSpPr>
-          <p:cNvPr id="20" name="Text 18"/>
-          <p:cNvSpPr/>
-          <p:nvPr/>
-        </p:nvSpPr>
-        <p:spPr>
-          <a:xfrm>
-            <a:off x="6830568" y="2167128"/>
-            <a:ext cx="237744" cy="237744"/>
-          </a:xfrm>
-          <a:prstGeom prst="rect">
-            <a:avLst/>
-          </a:prstGeom>
-          <a:noFill/>
-          <a:ln/>
-        </p:spPr>
-        <p:txBody>
-          <a:bodyPr wrap="square" lIns="0" tIns="0" rIns="0" bIns="0" rtlCol="0" anchor="ctr"/>
-          <a:lstStyle/>
-          <a:p>
-            <a:pPr algn="ctr" indent="0" marL="0">
-              <a:buNone/>
-            </a:pPr>
-            <a:r>
-              <a:rPr lang="en-US" sz="750" b="1" dirty="0">
-                <a:solidFill>
-                  <a:srgbClr val="FFFFFF"/>
-                </a:solidFill>
-                <a:latin typeface="Calibri" pitchFamily="34" charset="0"/>
-                <a:ea typeface="Calibri" pitchFamily="34" charset="-122"/>
-                <a:cs typeface="Calibri" pitchFamily="34" charset="-120"/>
-              </a:rPr>
-              <a:t>2028</a:t>
-            </a:r>
-            <a:endParaRPr lang="en-US" sz="750" dirty="0"/>
-          </a:p>
-        </p:txBody>
-      </p:sp>
-      <p:sp>
-        <p:nvSpPr>
-          <p:cNvPr id="21" name="Text 19"/>
-          <p:cNvSpPr/>
-          <p:nvPr/>
-        </p:nvSpPr>
-        <p:spPr>
-          <a:xfrm>
-            <a:off x="6217920" y="2606040"/>
-            <a:ext cx="1463040" cy="457200"/>
-          </a:xfrm>
-          <a:prstGeom prst="rect">
-            <a:avLst/>
-          </a:prstGeom>
-          <a:noFill/>
-          <a:ln/>
-        </p:spPr>
-        <p:txBody>
-          <a:bodyPr wrap="square" lIns="0" tIns="0" rIns="0" bIns="0" rtlCol="0" anchor="t"/>
-          <a:lstStyle/>
-          <a:p>
-            <a:pPr algn="ctr" indent="0" marL="0">
-              <a:buNone/>
-            </a:pPr>
-            <a:r>
-              <a:rPr lang="en-US" sz="850" dirty="0">
-                <a:solidFill>
-                  <a:srgbClr val="404040"/>
-                </a:solidFill>
-                <a:latin typeface="Calibri" pitchFamily="34" charset="0"/>
-                <a:ea typeface="Calibri" pitchFamily="34" charset="-122"/>
-                <a:cs typeface="Calibri" pitchFamily="34" charset="-120"/>
-              </a:rPr>
-              <a:t>HyNetwork backbone</a:t>
-            </a:r>
-            <a:endParaRPr lang="en-US" sz="850" dirty="0"/>
-          </a:p>
-          <a:p>
-            <a:pPr algn="ctr" indent="0" marL="0">
-              <a:buNone/>
-            </a:pPr>
-            <a:r>
-              <a:rPr lang="en-US" sz="850" dirty="0">
-                <a:solidFill>
-                  <a:srgbClr val="404040"/>
-                </a:solidFill>
-                <a:latin typeface="Calibri" pitchFamily="34" charset="0"/>
-                <a:ea typeface="Calibri" pitchFamily="34" charset="-122"/>
-                <a:cs typeface="Calibri" pitchFamily="34" charset="-120"/>
-              </a:rPr>
-              <a:t>pipeline live</a:t>
-            </a:r>
-            <a:endParaRPr lang="en-US" sz="850" dirty="0"/>
-          </a:p>
-        </p:txBody>
-      </p:sp>
-      <p:sp>
-        <p:nvSpPr>
-          <p:cNvPr id="22" name="Shape 20"/>
-          <p:cNvSpPr/>
-          <p:nvPr/>
-        </p:nvSpPr>
-        <p:spPr>
-          <a:xfrm>
-            <a:off x="8961120" y="2011680"/>
-            <a:ext cx="0" cy="274320"/>
-          </a:xfrm>
-          <a:prstGeom prst="line">
-            <a:avLst/>
-          </a:prstGeom>
-          <a:noFill/>
-          <a:ln w="12700">
-            <a:solidFill>
-              <a:srgbClr val="0C2340"/>
-            </a:solidFill>
-            <a:prstDash val="solid"/>
-          </a:ln>
-        </p:spPr>
-      </p:sp>
-      <p:sp>
-        <p:nvSpPr>
-          <p:cNvPr id="23" name="Shape 21"/>
-          <p:cNvSpPr/>
-          <p:nvPr/>
-        </p:nvSpPr>
-        <p:spPr>
-          <a:xfrm>
-            <a:off x="8842248" y="2167128"/>
-            <a:ext cx="237744" cy="237744"/>
-          </a:xfrm>
-          <a:prstGeom prst="ellipse">
-            <a:avLst/>
-          </a:prstGeom>
-          <a:solidFill>
-            <a:srgbClr val="0C2340"/>
-          </a:solidFill>
-          <a:ln/>
-        </p:spPr>
-      </p:sp>
-      <p:sp>
-        <p:nvSpPr>
-          <p:cNvPr id="24" name="Text 22"/>
-          <p:cNvSpPr/>
-          <p:nvPr/>
-        </p:nvSpPr>
-        <p:spPr>
-          <a:xfrm>
-            <a:off x="8842248" y="2167128"/>
-            <a:ext cx="237744" cy="237744"/>
-          </a:xfrm>
-          <a:prstGeom prst="rect">
-            <a:avLst/>
-          </a:prstGeom>
-          <a:noFill/>
-          <a:ln/>
-        </p:spPr>
-        <p:txBody>
-          <a:bodyPr wrap="square" lIns="0" tIns="0" rIns="0" bIns="0" rtlCol="0" anchor="ctr"/>
-          <a:lstStyle/>
-          <a:p>
-            <a:pPr algn="ctr" indent="0" marL="0">
-              <a:buNone/>
-            </a:pPr>
-            <a:r>
-              <a:rPr lang="en-US" sz="750" b="1" dirty="0">
-                <a:solidFill>
-                  <a:srgbClr val="FFFFFF"/>
-                </a:solidFill>
-                <a:latin typeface="Calibri" pitchFamily="34" charset="0"/>
-                <a:ea typeface="Calibri" pitchFamily="34" charset="-122"/>
-                <a:cs typeface="Calibri" pitchFamily="34" charset="-120"/>
-              </a:rPr>
-              <a:t>2030</a:t>
-            </a:r>
-            <a:endParaRPr lang="en-US" sz="750" dirty="0"/>
-          </a:p>
-        </p:txBody>
-      </p:sp>
-      <p:sp>
-        <p:nvSpPr>
-          <p:cNvPr id="25" name="Text 23"/>
-          <p:cNvSpPr/>
-          <p:nvPr/>
-        </p:nvSpPr>
-        <p:spPr>
-          <a:xfrm>
-            <a:off x="8229600" y="1508760"/>
-            <a:ext cx="1463040" cy="457200"/>
-          </a:xfrm>
-          <a:prstGeom prst="rect">
-            <a:avLst/>
-          </a:prstGeom>
-          <a:noFill/>
-          <a:ln/>
-        </p:spPr>
-        <p:txBody>
-          <a:bodyPr wrap="square" lIns="0" tIns="0" rIns="0" bIns="0" rtlCol="0" anchor="b"/>
-          <a:lstStyle/>
-          <a:p>
-            <a:pPr algn="ctr" indent="0" marL="0">
-              <a:buNone/>
-            </a:pPr>
-            <a:r>
-              <a:rPr lang="en-US" sz="850" dirty="0">
-                <a:solidFill>
-                  <a:srgbClr val="404040"/>
-                </a:solidFill>
-                <a:latin typeface="Calibri" pitchFamily="34" charset="0"/>
-                <a:ea typeface="Calibri" pitchFamily="34" charset="-122"/>
-                <a:cs typeface="Calibri" pitchFamily="34" charset="-120"/>
-              </a:rPr>
-              <a:t>Scale-up phase</a:t>
-            </a:r>
-            <a:endParaRPr lang="en-US" sz="850" dirty="0"/>
-          </a:p>
-          <a:p>
-            <a:pPr algn="ctr" indent="0" marL="0">
-              <a:buNone/>
-            </a:pPr>
-            <a:r>
-              <a:rPr lang="en-US" sz="850" dirty="0">
-                <a:solidFill>
-                  <a:srgbClr val="404040"/>
-                </a:solidFill>
-                <a:latin typeface="Calibri" pitchFamily="34" charset="0"/>
-                <a:ea typeface="Calibri" pitchFamily="34" charset="-122"/>
-                <a:cs typeface="Calibri" pitchFamily="34" charset="-120"/>
-              </a:rPr>
-              <a:t>complete</a:t>
-            </a:r>
-            <a:endParaRPr lang="en-US" sz="850" dirty="0"/>
-          </a:p>
-        </p:txBody>
-      </p:sp>
-      <p:sp>
-        <p:nvSpPr>
-          <p:cNvPr id="26" name="Shape 24"/>
-          <p:cNvSpPr/>
-          <p:nvPr/>
-        </p:nvSpPr>
-        <p:spPr>
-          <a:xfrm>
-            <a:off x="10972800" y="2286000"/>
-            <a:ext cx="0" cy="274320"/>
-          </a:xfrm>
-          <a:prstGeom prst="line">
-            <a:avLst/>
-          </a:prstGeom>
-          <a:noFill/>
-          <a:ln w="12700">
-            <a:solidFill>
-              <a:srgbClr val="0C2340"/>
-            </a:solidFill>
-            <a:prstDash val="solid"/>
-          </a:ln>
-        </p:spPr>
-      </p:sp>
-      <p:sp>
-        <p:nvSpPr>
-          <p:cNvPr id="27" name="Shape 25"/>
-          <p:cNvSpPr/>
-          <p:nvPr/>
-        </p:nvSpPr>
-        <p:spPr>
-          <a:xfrm>
-            <a:off x="10853928" y="2167128"/>
-            <a:ext cx="237744" cy="237744"/>
-          </a:xfrm>
-          <a:prstGeom prst="ellipse">
-            <a:avLst/>
-          </a:prstGeom>
-          <a:solidFill>
-            <a:srgbClr val="0C2340"/>
-          </a:solidFill>
-          <a:ln/>
-        </p:spPr>
-      </p:sp>
-      <p:sp>
-        <p:nvSpPr>
-          <p:cNvPr id="28" name="Text 26"/>
-          <p:cNvSpPr/>
-          <p:nvPr/>
-        </p:nvSpPr>
-        <p:spPr>
-          <a:xfrm>
-            <a:off x="10853928" y="2167128"/>
-            <a:ext cx="237744" cy="237744"/>
-          </a:xfrm>
-          <a:prstGeom prst="rect">
-            <a:avLst/>
-          </a:prstGeom>
-          <a:noFill/>
-          <a:ln/>
-        </p:spPr>
-        <p:txBody>
-          <a:bodyPr wrap="square" lIns="0" tIns="0" rIns="0" bIns="0" rtlCol="0" anchor="ctr"/>
-          <a:lstStyle/>
-          <a:p>
-            <a:pPr algn="ctr" indent="0" marL="0">
-              <a:buNone/>
-            </a:pPr>
-            <a:r>
-              <a:rPr lang="en-US" sz="750" b="1" dirty="0">
-                <a:solidFill>
-                  <a:srgbClr val="FFFFFF"/>
-                </a:solidFill>
-                <a:latin typeface="Calibri" pitchFamily="34" charset="0"/>
-                <a:ea typeface="Calibri" pitchFamily="34" charset="-122"/>
-                <a:cs typeface="Calibri" pitchFamily="34" charset="-120"/>
-              </a:rPr>
-              <a:t>2035</a:t>
-            </a:r>
-            <a:endParaRPr lang="en-US" sz="750" dirty="0"/>
-          </a:p>
-        </p:txBody>
-      </p:sp>
-      <p:sp>
-        <p:nvSpPr>
-          <p:cNvPr id="29" name="Text 27"/>
-          <p:cNvSpPr/>
-          <p:nvPr/>
-        </p:nvSpPr>
-        <p:spPr>
-          <a:xfrm>
-            <a:off x="10241280" y="2606040"/>
-            <a:ext cx="1463040" cy="457200"/>
-          </a:xfrm>
-          <a:prstGeom prst="rect">
-            <a:avLst/>
-          </a:prstGeom>
-          <a:noFill/>
-          <a:ln/>
-        </p:spPr>
-        <p:txBody>
-          <a:bodyPr wrap="square" lIns="0" tIns="0" rIns="0" bIns="0" rtlCol="0" anchor="t"/>
-          <a:lstStyle/>
-          <a:p>
-            <a:pPr algn="ctr" indent="0" marL="0">
-              <a:buNone/>
-            </a:pPr>
-            <a:r>
-              <a:rPr lang="en-US" sz="850" dirty="0">
-                <a:solidFill>
-                  <a:srgbClr val="404040"/>
-                </a:solidFill>
-                <a:latin typeface="Calibri" pitchFamily="34" charset="0"/>
-                <a:ea typeface="Calibri" pitchFamily="34" charset="-122"/>
-                <a:cs typeface="Calibri" pitchFamily="34" charset="-120"/>
-              </a:rPr>
-              <a:t>EU hydrogen corridor</a:t>
-            </a:r>
-            <a:endParaRPr lang="en-US" sz="850" dirty="0"/>
-          </a:p>
-          <a:p>
-            <a:pPr algn="ctr" indent="0" marL="0">
-              <a:buNone/>
-            </a:pPr>
-            <a:r>
-              <a:rPr lang="en-US" sz="850" dirty="0">
-                <a:solidFill>
-                  <a:srgbClr val="404040"/>
-                </a:solidFill>
-                <a:latin typeface="Calibri" pitchFamily="34" charset="0"/>
-                <a:ea typeface="Calibri" pitchFamily="34" charset="-122"/>
-                <a:cs typeface="Calibri" pitchFamily="34" charset="-120"/>
-              </a:rPr>
-              <a:t>integration</a:t>
-            </a:r>
-            <a:endParaRPr lang="en-US" sz="850" dirty="0"/>
+            <a:endParaRPr lang="en-US" sz="650" dirty="0"/>
           </a:p>
         </p:txBody>
       </p:sp>
@@ -1842,49 +1073,32 @@
           </p:nvPr>
         </p:nvGraphicFramePr>
         <p:xfrm>
-          <a:off x="457200" y="3200400"/>
-          <a:ext cx="11274552" cy="914400"/>
+          <a:off x="457200" y="1152144"/>
+          <a:ext cx="8229600" cy="2560320"/>
         </p:xfrm>
         <a:graphic>
           <a:graphicData uri="http://schemas.openxmlformats.org/drawingml/2006/table">
             <a:tbl>
               <a:tblPr/>
               <a:tblGrid>
-                <a:gridCol w="2130552"/>
-                <a:gridCol w="1828800"/>
-                <a:gridCol w="1828800"/>
-                <a:gridCol w="1828800"/>
-                <a:gridCol w="1828800"/>
-                <a:gridCol w="1828800"/>
+                <a:gridCol w="1371600"/>
+                <a:gridCol w="2286000"/>
+                <a:gridCol w="2286000"/>
+                <a:gridCol w="2286000"/>
               </a:tblGrid>
-              <a:tr h="320040">
+              <a:tr h="274320">
                 <a:tc>
                   <a:txBody>
                     <a:bodyPr/>
                     <a:lstStyle/>
                     <a:p>
-                      <a:pPr algn="l" indent="0" marL="0">
-                        <a:buNone/>
-                      </a:pPr>
-                      <a:r>
-                        <a:rPr lang="en-US" sz="900" b="1" dirty="0">
-                          <a:solidFill>
-                            <a:srgbClr val="0C2340"/>
-                          </a:solidFill>
-                          <a:latin typeface="Calibri" pitchFamily="34" charset="0"/>
-                          <a:ea typeface="Calibri" pitchFamily="34" charset="-122"/>
-                          <a:cs typeface="Calibri" pitchFamily="34" charset="-120"/>
-                        </a:rPr>
-                        <a:t>Metric</a:t>
-                      </a:r>
-                      <a:endParaRPr lang="en-US" sz="900" dirty="0">
-                        <a:latin typeface="Calibri" charset="0"/>
-                        <a:ea typeface="Calibri" charset="0"/>
-                        <a:cs typeface="Calibri" charset="0"/>
-                      </a:endParaRPr>
+                      <a:pPr indent="0" marL="0">
+                        <a:buNone/>
+                      </a:pPr>
+                      <a:endParaRPr lang="en-US" sz="850" dirty="0"/>
                     </a:p>
                   </a:txBody>
-                  <a:tcPr marL="50800" marR="50800" marT="25400" marB="25400">
+                  <a:tcPr marL="91440" marR="91440" marT="45720" marB="45720">
                     <a:lnL w="0" cap="flat" cmpd="sng" algn="ctr">
                       <a:solidFill>
                         <a:srgbClr val="FFFFFF"/>
@@ -1903,24 +1117,27 @@
                       <a:headEnd type="none" w="med" len="med"/>
                       <a:tailEnd type="none" w="med" len="med"/>
                     </a:lnR>
-                    <a:lnT w="19050" cap="flat" cmpd="sng" algn="ctr">
-                      <a:solidFill>
-                        <a:srgbClr val="0C2340"/>
+                    <a:lnT w="0" cap="flat" cmpd="sng" algn="ctr">
+                      <a:solidFill>
+                        <a:srgbClr val="FFFFFF"/>
                       </a:solidFill>
                       <a:prstDash val="solid"/>
                       <a:round/>
                       <a:headEnd type="none" w="med" len="med"/>
                       <a:tailEnd type="none" w="med" len="med"/>
                     </a:lnT>
-                    <a:lnB w="19050" cap="flat" cmpd="sng" algn="ctr">
-                      <a:solidFill>
-                        <a:srgbClr val="0C2340"/>
+                    <a:lnB w="12700" cap="flat" cmpd="sng" algn="ctr">
+                      <a:solidFill>
+                        <a:srgbClr val="333333"/>
                       </a:solidFill>
                       <a:prstDash val="solid"/>
                       <a:round/>
                       <a:headEnd type="none" w="med" len="med"/>
                       <a:tailEnd type="none" w="med" len="med"/>
                     </a:lnB>
+                    <a:solidFill>
+                      <a:srgbClr val="FFFFFF"/>
+                    </a:solidFill>
                   </a:tcPr>
                 </a:tc>
                 <a:tc>
@@ -1934,13 +1151,13 @@
                       <a:r>
                         <a:rPr lang="en-US" sz="900" b="1" dirty="0">
                           <a:solidFill>
-                            <a:srgbClr val="0C2340"/>
-                          </a:solidFill>
-                          <a:latin typeface="Calibri" pitchFamily="34" charset="0"/>
-                          <a:ea typeface="Calibri" pitchFamily="34" charset="-122"/>
-                          <a:cs typeface="Calibri" pitchFamily="34" charset="-120"/>
-                        </a:rPr>
-                        <a:t>2020</a:t>
+                            <a:srgbClr val="000000"/>
+                          </a:solidFill>
+                          <a:latin typeface="Calibri" pitchFamily="34" charset="0"/>
+                          <a:ea typeface="Calibri" pitchFamily="34" charset="-122"/>
+                          <a:cs typeface="Calibri" pitchFamily="34" charset="-120"/>
+                        </a:rPr>
+                        <a:t>Grey</a:t>
                       </a:r>
                       <a:endParaRPr lang="en-US" sz="900" dirty="0">
                         <a:latin typeface="Calibri" charset="0"/>
@@ -1948,8 +1165,29 @@
                         <a:cs typeface="Calibri" charset="0"/>
                       </a:endParaRPr>
                     </a:p>
+                    <a:p>
+                      <a:pPr algn="ctr" indent="0" marL="0">
+                        <a:buNone/>
+                      </a:pPr>
+                      <a:r>
+                        <a:rPr lang="en-US" sz="900" b="1" dirty="0">
+                          <a:solidFill>
+                            <a:srgbClr val="000000"/>
+                          </a:solidFill>
+                          <a:latin typeface="Calibri" pitchFamily="34" charset="0"/>
+                          <a:ea typeface="Calibri" pitchFamily="34" charset="-122"/>
+                          <a:cs typeface="Calibri" pitchFamily="34" charset="-120"/>
+                        </a:rPr>
+                        <a:t>H2</a:t>
+                      </a:r>
+                      <a:endParaRPr lang="en-US" sz="900" dirty="0">
+                        <a:latin typeface="Calibri" charset="0"/>
+                        <a:ea typeface="Calibri" charset="0"/>
+                        <a:cs typeface="Calibri" charset="0"/>
+                      </a:endParaRPr>
+                    </a:p>
                   </a:txBody>
-                  <a:tcPr marL="50800" marR="50800" marT="25400" marB="25400">
+                  <a:tcPr marL="91440" marR="91440" marT="45720" marB="45720" anchor="ctr">
                     <a:lnL w="0" cap="flat" cmpd="sng" algn="ctr">
                       <a:solidFill>
                         <a:srgbClr val="FFFFFF"/>
@@ -1968,24 +1206,27 @@
                       <a:headEnd type="none" w="med" len="med"/>
                       <a:tailEnd type="none" w="med" len="med"/>
                     </a:lnR>
-                    <a:lnT w="19050" cap="flat" cmpd="sng" algn="ctr">
-                      <a:solidFill>
-                        <a:srgbClr val="0C2340"/>
+                    <a:lnT w="0" cap="flat" cmpd="sng" algn="ctr">
+                      <a:solidFill>
+                        <a:srgbClr val="FFFFFF"/>
                       </a:solidFill>
                       <a:prstDash val="solid"/>
                       <a:round/>
                       <a:headEnd type="none" w="med" len="med"/>
                       <a:tailEnd type="none" w="med" len="med"/>
                     </a:lnT>
-                    <a:lnB w="19050" cap="flat" cmpd="sng" algn="ctr">
-                      <a:solidFill>
-                        <a:srgbClr val="0C2340"/>
+                    <a:lnB w="12700" cap="flat" cmpd="sng" algn="ctr">
+                      <a:solidFill>
+                        <a:srgbClr val="333333"/>
                       </a:solidFill>
                       <a:prstDash val="solid"/>
                       <a:round/>
                       <a:headEnd type="none" w="med" len="med"/>
                       <a:tailEnd type="none" w="med" len="med"/>
                     </a:lnB>
+                    <a:solidFill>
+                      <a:srgbClr val="FFFFFF"/>
+                    </a:solidFill>
                   </a:tcPr>
                 </a:tc>
                 <a:tc>
@@ -1999,13 +1240,13 @@
                       <a:r>
                         <a:rPr lang="en-US" sz="900" b="1" dirty="0">
                           <a:solidFill>
-                            <a:srgbClr val="0C2340"/>
-                          </a:solidFill>
-                          <a:latin typeface="Calibri" pitchFamily="34" charset="0"/>
-                          <a:ea typeface="Calibri" pitchFamily="34" charset="-122"/>
-                          <a:cs typeface="Calibri" pitchFamily="34" charset="-120"/>
-                        </a:rPr>
-                        <a:t>2025</a:t>
+                            <a:srgbClr val="000000"/>
+                          </a:solidFill>
+                          <a:latin typeface="Calibri" pitchFamily="34" charset="0"/>
+                          <a:ea typeface="Calibri" pitchFamily="34" charset="-122"/>
+                          <a:cs typeface="Calibri" pitchFamily="34" charset="-120"/>
+                        </a:rPr>
+                        <a:t>Blue</a:t>
                       </a:r>
                       <a:endParaRPr lang="en-US" sz="900" dirty="0">
                         <a:latin typeface="Calibri" charset="0"/>
@@ -2013,8 +1254,29 @@
                         <a:cs typeface="Calibri" charset="0"/>
                       </a:endParaRPr>
                     </a:p>
+                    <a:p>
+                      <a:pPr algn="ctr" indent="0" marL="0">
+                        <a:buNone/>
+                      </a:pPr>
+                      <a:r>
+                        <a:rPr lang="en-US" sz="900" b="1" dirty="0">
+                          <a:solidFill>
+                            <a:srgbClr val="000000"/>
+                          </a:solidFill>
+                          <a:latin typeface="Calibri" pitchFamily="34" charset="0"/>
+                          <a:ea typeface="Calibri" pitchFamily="34" charset="-122"/>
+                          <a:cs typeface="Calibri" pitchFamily="34" charset="-120"/>
+                        </a:rPr>
+                        <a:t>H2</a:t>
+                      </a:r>
+                      <a:endParaRPr lang="en-US" sz="900" dirty="0">
+                        <a:latin typeface="Calibri" charset="0"/>
+                        <a:ea typeface="Calibri" charset="0"/>
+                        <a:cs typeface="Calibri" charset="0"/>
+                      </a:endParaRPr>
+                    </a:p>
                   </a:txBody>
-                  <a:tcPr marL="50800" marR="50800" marT="25400" marB="25400">
+                  <a:tcPr marL="91440" marR="91440" marT="45720" marB="45720" anchor="ctr">
                     <a:lnL w="0" cap="flat" cmpd="sng" algn="ctr">
                       <a:solidFill>
                         <a:srgbClr val="FFFFFF"/>
@@ -2033,24 +1295,27 @@
                       <a:headEnd type="none" w="med" len="med"/>
                       <a:tailEnd type="none" w="med" len="med"/>
                     </a:lnR>
-                    <a:lnT w="19050" cap="flat" cmpd="sng" algn="ctr">
-                      <a:solidFill>
-                        <a:srgbClr val="0C2340"/>
+                    <a:lnT w="0" cap="flat" cmpd="sng" algn="ctr">
+                      <a:solidFill>
+                        <a:srgbClr val="FFFFFF"/>
                       </a:solidFill>
                       <a:prstDash val="solid"/>
                       <a:round/>
                       <a:headEnd type="none" w="med" len="med"/>
                       <a:tailEnd type="none" w="med" len="med"/>
                     </a:lnT>
-                    <a:lnB w="19050" cap="flat" cmpd="sng" algn="ctr">
-                      <a:solidFill>
-                        <a:srgbClr val="0C2340"/>
+                    <a:lnB w="12700" cap="flat" cmpd="sng" algn="ctr">
+                      <a:solidFill>
+                        <a:srgbClr val="333333"/>
                       </a:solidFill>
                       <a:prstDash val="solid"/>
                       <a:round/>
                       <a:headEnd type="none" w="med" len="med"/>
                       <a:tailEnd type="none" w="med" len="med"/>
                     </a:lnB>
+                    <a:solidFill>
+                      <a:srgbClr val="FFFFFF"/>
+                    </a:solidFill>
                   </a:tcPr>
                 </a:tc>
                 <a:tc>
@@ -2064,13 +1329,13 @@
                       <a:r>
                         <a:rPr lang="en-US" sz="900" b="1" dirty="0">
                           <a:solidFill>
-                            <a:srgbClr val="0C2340"/>
-                          </a:solidFill>
-                          <a:latin typeface="Calibri" pitchFamily="34" charset="0"/>
-                          <a:ea typeface="Calibri" pitchFamily="34" charset="-122"/>
-                          <a:cs typeface="Calibri" pitchFamily="34" charset="-120"/>
-                        </a:rPr>
-                        <a:t>2028</a:t>
+                            <a:srgbClr val="000000"/>
+                          </a:solidFill>
+                          <a:latin typeface="Calibri" pitchFamily="34" charset="0"/>
+                          <a:ea typeface="Calibri" pitchFamily="34" charset="-122"/>
+                          <a:cs typeface="Calibri" pitchFamily="34" charset="-120"/>
+                        </a:rPr>
+                        <a:t>Green</a:t>
                       </a:r>
                       <a:endParaRPr lang="en-US" sz="900" dirty="0">
                         <a:latin typeface="Calibri" charset="0"/>
@@ -2078,8 +1343,29 @@
                         <a:cs typeface="Calibri" charset="0"/>
                       </a:endParaRPr>
                     </a:p>
+                    <a:p>
+                      <a:pPr algn="ctr" indent="0" marL="0">
+                        <a:buNone/>
+                      </a:pPr>
+                      <a:r>
+                        <a:rPr lang="en-US" sz="900" b="1" dirty="0">
+                          <a:solidFill>
+                            <a:srgbClr val="000000"/>
+                          </a:solidFill>
+                          <a:latin typeface="Calibri" pitchFamily="34" charset="0"/>
+                          <a:ea typeface="Calibri" pitchFamily="34" charset="-122"/>
+                          <a:cs typeface="Calibri" pitchFamily="34" charset="-120"/>
+                        </a:rPr>
+                        <a:t>H2</a:t>
+                      </a:r>
+                      <a:endParaRPr lang="en-US" sz="900" dirty="0">
+                        <a:latin typeface="Calibri" charset="0"/>
+                        <a:ea typeface="Calibri" charset="0"/>
+                        <a:cs typeface="Calibri" charset="0"/>
+                      </a:endParaRPr>
+                    </a:p>
                   </a:txBody>
-                  <a:tcPr marL="50800" marR="50800" marT="25400" marB="25400">
+                  <a:tcPr marL="91440" marR="91440" marT="45720" marB="45720" anchor="ctr">
                     <a:lnL w="0" cap="flat" cmpd="sng" algn="ctr">
                       <a:solidFill>
                         <a:srgbClr val="FFFFFF"/>
@@ -2098,24 +1384,118 @@
                       <a:headEnd type="none" w="med" len="med"/>
                       <a:tailEnd type="none" w="med" len="med"/>
                     </a:lnR>
-                    <a:lnT w="19050" cap="flat" cmpd="sng" algn="ctr">
-                      <a:solidFill>
-                        <a:srgbClr val="0C2340"/>
+                    <a:lnT w="0" cap="flat" cmpd="sng" algn="ctr">
+                      <a:solidFill>
+                        <a:srgbClr val="FFFFFF"/>
                       </a:solidFill>
                       <a:prstDash val="solid"/>
                       <a:round/>
                       <a:headEnd type="none" w="med" len="med"/>
                       <a:tailEnd type="none" w="med" len="med"/>
                     </a:lnT>
-                    <a:lnB w="19050" cap="flat" cmpd="sng" algn="ctr">
-                      <a:solidFill>
-                        <a:srgbClr val="0C2340"/>
+                    <a:lnB w="12700" cap="flat" cmpd="sng" algn="ctr">
+                      <a:solidFill>
+                        <a:srgbClr val="333333"/>
                       </a:solidFill>
                       <a:prstDash val="solid"/>
                       <a:round/>
                       <a:headEnd type="none" w="med" len="med"/>
                       <a:tailEnd type="none" w="med" len="med"/>
                     </a:lnB>
+                    <a:solidFill>
+                      <a:srgbClr val="FFFFFF"/>
+                    </a:solidFill>
+                  </a:tcPr>
+                </a:tc>
+              </a:tr>
+              <a:tr h="384048">
+                <a:tc>
+                  <a:txBody>
+                    <a:bodyPr/>
+                    <a:lstStyle/>
+                    <a:p>
+                      <a:pPr indent="0" marL="0">
+                        <a:buNone/>
+                      </a:pPr>
+                      <a:r>
+                        <a:rPr lang="en-US" sz="850" b="1" dirty="0">
+                          <a:solidFill>
+                            <a:srgbClr val="000000"/>
+                          </a:solidFill>
+                          <a:latin typeface="Calibri" pitchFamily="34" charset="0"/>
+                          <a:ea typeface="Calibri" pitchFamily="34" charset="-122"/>
+                          <a:cs typeface="Calibri" pitchFamily="34" charset="-120"/>
+                        </a:rPr>
+                        <a:t>Production</a:t>
+                      </a:r>
+                      <a:endParaRPr lang="en-US" sz="850" dirty="0">
+                        <a:latin typeface="Calibri" charset="0"/>
+                        <a:ea typeface="Calibri" charset="0"/>
+                        <a:cs typeface="Calibri" charset="0"/>
+                      </a:endParaRPr>
+                    </a:p>
+                    <a:p>
+                      <a:pPr indent="0" marL="0">
+                        <a:buNone/>
+                      </a:pPr>
+                      <a:r>
+                        <a:rPr lang="en-US" sz="850" b="1" dirty="0">
+                          <a:solidFill>
+                            <a:srgbClr val="000000"/>
+                          </a:solidFill>
+                          <a:latin typeface="Calibri" pitchFamily="34" charset="0"/>
+                          <a:ea typeface="Calibri" pitchFamily="34" charset="-122"/>
+                          <a:cs typeface="Calibri" pitchFamily="34" charset="-120"/>
+                        </a:rPr>
+                        <a:t>process</a:t>
+                      </a:r>
+                      <a:endParaRPr lang="en-US" sz="850" dirty="0">
+                        <a:latin typeface="Calibri" charset="0"/>
+                        <a:ea typeface="Calibri" charset="0"/>
+                        <a:cs typeface="Calibri" charset="0"/>
+                      </a:endParaRPr>
+                    </a:p>
+                  </a:txBody>
+                  <a:tcPr marL="91440" marR="91440" marT="45720" marB="45720" anchor="ctr">
+                    <a:lnL w="0" cap="flat" cmpd="sng" algn="ctr">
+                      <a:solidFill>
+                        <a:srgbClr val="FFFFFF"/>
+                      </a:solidFill>
+                      <a:prstDash val="solid"/>
+                      <a:round/>
+                      <a:headEnd type="none" w="med" len="med"/>
+                      <a:tailEnd type="none" w="med" len="med"/>
+                    </a:lnL>
+                    <a:lnR w="0" cap="flat" cmpd="sng" algn="ctr">
+                      <a:solidFill>
+                        <a:srgbClr val="FFFFFF"/>
+                      </a:solidFill>
+                      <a:prstDash val="solid"/>
+                      <a:round/>
+                      <a:headEnd type="none" w="med" len="med"/>
+                      <a:tailEnd type="none" w="med" len="med"/>
+                    </a:lnR>
+                    <a:lnT w="6350" cap="flat" cmpd="sng" algn="ctr">
+                      <a:solidFill>
+                        <a:srgbClr val="D0D0D0"/>
+                      </a:solidFill>
+                      <a:prstDash val="solid"/>
+                      <a:round/>
+                      <a:headEnd type="none" w="med" len="med"/>
+                      <a:tailEnd type="none" w="med" len="med"/>
+                    </a:lnT>
+                    <a:lnB w="6350" cap="flat" cmpd="sng" algn="ctr">
+                      <a:solidFill>
+                        <a:srgbClr val="D0D0D0"/>
+                      </a:solidFill>
+                      <a:prstDash val="solid"/>
+                      <a:round/>
+                      <a:headEnd type="none" w="med" len="med"/>
+                      <a:tailEnd type="none" w="med" len="med"/>
+                    </a:lnB>
+                    <a:solidFill>
+                      <a:srgbClr val="FFFFFF"/>
+                    </a:solidFill>
                   </a:tcPr>
                 </a:tc>
                 <a:tc>
@@ -2123,28 +1503,49 @@
                     <a:bodyPr/>
                     <a:lstStyle/>
                     <a:p>
-                      <a:pPr algn="ctr" indent="0" marL="0">
-                        <a:buNone/>
-                      </a:pPr>
-                      <a:r>
-                        <a:rPr lang="en-US" sz="900" b="1" dirty="0">
-                          <a:solidFill>
-                            <a:srgbClr val="0C2340"/>
-                          </a:solidFill>
-                          <a:latin typeface="Calibri" pitchFamily="34" charset="0"/>
-                          <a:ea typeface="Calibri" pitchFamily="34" charset="-122"/>
-                          <a:cs typeface="Calibri" pitchFamily="34" charset="-120"/>
-                        </a:rPr>
-                        <a:t>2030</a:t>
-                      </a:r>
-                      <a:endParaRPr lang="en-US" sz="900" dirty="0">
+                      <a:pPr indent="0" marL="0">
+                        <a:buNone/>
+                      </a:pPr>
+                      <a:r>
+                        <a:rPr lang="en-US" sz="850" dirty="0">
+                          <a:solidFill>
+                            <a:srgbClr val="333333"/>
+                          </a:solidFill>
+                          <a:latin typeface="Calibri" pitchFamily="34" charset="0"/>
+                          <a:ea typeface="Calibri" pitchFamily="34" charset="-122"/>
+                          <a:cs typeface="Calibri" pitchFamily="34" charset="-120"/>
+                        </a:rPr>
+                        <a:t>Split¹ natural gas</a:t>
+                      </a:r>
+                      <a:endParaRPr lang="en-US" sz="850" dirty="0">
+                        <a:latin typeface="Calibri" charset="0"/>
+                        <a:ea typeface="Calibri" charset="0"/>
+                        <a:cs typeface="Calibri" charset="0"/>
+                      </a:endParaRPr>
+                    </a:p>
+                    <a:p>
+                      <a:pPr indent="0" marL="0">
+                        <a:buNone/>
+                      </a:pPr>
+                      <a:r>
+                        <a:rPr lang="en-US" sz="850" dirty="0">
+                          <a:solidFill>
+                            <a:srgbClr val="333333"/>
+                          </a:solidFill>
+                          <a:latin typeface="Calibri" pitchFamily="34" charset="0"/>
+                          <a:ea typeface="Calibri" pitchFamily="34" charset="-122"/>
+                          <a:cs typeface="Calibri" pitchFamily="34" charset="-120"/>
+                        </a:rPr>
+                        <a:t>into H2 and CO2</a:t>
+                      </a:r>
+                      <a:endParaRPr lang="en-US" sz="850" dirty="0">
                         <a:latin typeface="Calibri" charset="0"/>
                         <a:ea typeface="Calibri" charset="0"/>
                         <a:cs typeface="Calibri" charset="0"/>
                       </a:endParaRPr>
                     </a:p>
                   </a:txBody>
-                  <a:tcPr marL="50800" marR="50800" marT="25400" marB="25400">
+                  <a:tcPr marL="91440" marR="91440" marT="45720" marB="45720" anchor="ctr">
                     <a:lnL w="0" cap="flat" cmpd="sng" algn="ctr">
                       <a:solidFill>
                         <a:srgbClr val="FFFFFF"/>
@@ -2163,24 +1564,27 @@
                       <a:headEnd type="none" w="med" len="med"/>
                       <a:tailEnd type="none" w="med" len="med"/>
                     </a:lnR>
-                    <a:lnT w="19050" cap="flat" cmpd="sng" algn="ctr">
-                      <a:solidFill>
-                        <a:srgbClr val="0C2340"/>
+                    <a:lnT w="6350" cap="flat" cmpd="sng" algn="ctr">
+                      <a:solidFill>
+                        <a:srgbClr val="D0D0D0"/>
                       </a:solidFill>
                       <a:prstDash val="solid"/>
                       <a:round/>
                       <a:headEnd type="none" w="med" len="med"/>
                       <a:tailEnd type="none" w="med" len="med"/>
                     </a:lnT>
-                    <a:lnB w="19050" cap="flat" cmpd="sng" algn="ctr">
-                      <a:solidFill>
-                        <a:srgbClr val="0C2340"/>
+                    <a:lnB w="6350" cap="flat" cmpd="sng" algn="ctr">
+                      <a:solidFill>
+                        <a:srgbClr val="D0D0D0"/>
                       </a:solidFill>
                       <a:prstDash val="solid"/>
                       <a:round/>
                       <a:headEnd type="none" w="med" len="med"/>
                       <a:tailEnd type="none" w="med" len="med"/>
                     </a:lnB>
+                    <a:solidFill>
+                      <a:srgbClr val="FFFFFF"/>
+                    </a:solidFill>
                   </a:tcPr>
                 </a:tc>
                 <a:tc>
@@ -2188,28 +1592,70 @@
                     <a:bodyPr/>
                     <a:lstStyle/>
                     <a:p>
-                      <a:pPr algn="ctr" indent="0" marL="0">
-                        <a:buNone/>
-                      </a:pPr>
-                      <a:r>
-                        <a:rPr lang="en-US" sz="900" b="1" dirty="0">
-                          <a:solidFill>
-                            <a:srgbClr val="0C2340"/>
-                          </a:solidFill>
-                          <a:latin typeface="Calibri" pitchFamily="34" charset="0"/>
-                          <a:ea typeface="Calibri" pitchFamily="34" charset="-122"/>
-                          <a:cs typeface="Calibri" pitchFamily="34" charset="-120"/>
-                        </a:rPr>
-                        <a:t>2035</a:t>
-                      </a:r>
-                      <a:endParaRPr lang="en-US" sz="900" dirty="0">
+                      <a:pPr indent="0" marL="0">
+                        <a:buNone/>
+                      </a:pPr>
+                      <a:r>
+                        <a:rPr lang="en-US" sz="850" dirty="0">
+                          <a:solidFill>
+                            <a:srgbClr val="333333"/>
+                          </a:solidFill>
+                          <a:latin typeface="Calibri" pitchFamily="34" charset="0"/>
+                          <a:ea typeface="Calibri" pitchFamily="34" charset="-122"/>
+                          <a:cs typeface="Calibri" pitchFamily="34" charset="-120"/>
+                        </a:rPr>
+                        <a:t>Similar to Grey but additionally</a:t>
+                      </a:r>
+                      <a:endParaRPr lang="en-US" sz="850" dirty="0">
+                        <a:latin typeface="Calibri" charset="0"/>
+                        <a:ea typeface="Calibri" charset="0"/>
+                        <a:cs typeface="Calibri" charset="0"/>
+                      </a:endParaRPr>
+                    </a:p>
+                    <a:p>
+                      <a:pPr indent="0" marL="0">
+                        <a:buNone/>
+                      </a:pPr>
+                      <a:r>
+                        <a:rPr lang="en-US" sz="850" dirty="0">
+                          <a:solidFill>
+                            <a:srgbClr val="333333"/>
+                          </a:solidFill>
+                          <a:latin typeface="Calibri" pitchFamily="34" charset="0"/>
+                          <a:ea typeface="Calibri" pitchFamily="34" charset="-122"/>
+                          <a:cs typeface="Calibri" pitchFamily="34" charset="-120"/>
+                        </a:rPr>
+                        <a:t>capture, potentially use, and</a:t>
+                      </a:r>
+                      <a:endParaRPr lang="en-US" sz="850" dirty="0">
+                        <a:latin typeface="Calibri" charset="0"/>
+                        <a:ea typeface="Calibri" charset="0"/>
+                        <a:cs typeface="Calibri" charset="0"/>
+                      </a:endParaRPr>
+                    </a:p>
+                    <a:p>
+                      <a:pPr indent="0" marL="0">
+                        <a:buNone/>
+                      </a:pPr>
+                      <a:r>
+                        <a:rPr lang="en-US" sz="850" dirty="0">
+                          <a:solidFill>
+                            <a:srgbClr val="333333"/>
+                          </a:solidFill>
+                          <a:latin typeface="Calibri" pitchFamily="34" charset="0"/>
+                          <a:ea typeface="Calibri" pitchFamily="34" charset="-122"/>
+                          <a:cs typeface="Calibri" pitchFamily="34" charset="-120"/>
+                        </a:rPr>
+                        <a:t>store CO2</a:t>
+                      </a:r>
+                      <a:endParaRPr lang="en-US" sz="850" dirty="0">
                         <a:latin typeface="Calibri" charset="0"/>
                         <a:ea typeface="Calibri" charset="0"/>
                         <a:cs typeface="Calibri" charset="0"/>
                       </a:endParaRPr>
                     </a:p>
                   </a:txBody>
-                  <a:tcPr marL="50800" marR="50800" marT="25400" marB="25400">
+                  <a:tcPr marL="91440" marR="91440" marT="45720" marB="45720" anchor="ctr">
                     <a:lnL w="0" cap="flat" cmpd="sng" algn="ctr">
                       <a:solidFill>
                         <a:srgbClr val="FFFFFF"/>
@@ -2228,76 +1674,9 @@
                       <a:headEnd type="none" w="med" len="med"/>
                       <a:tailEnd type="none" w="med" len="med"/>
                     </a:lnR>
-                    <a:lnT w="19050" cap="flat" cmpd="sng" algn="ctr">
-                      <a:solidFill>
-                        <a:srgbClr val="0C2340"/>
-                      </a:solidFill>
-                      <a:prstDash val="solid"/>
-                      <a:round/>
-                      <a:headEnd type="none" w="med" len="med"/>
-                      <a:tailEnd type="none" w="med" len="med"/>
-                    </a:lnT>
-                    <a:lnB w="19050" cap="flat" cmpd="sng" algn="ctr">
-                      <a:solidFill>
-                        <a:srgbClr val="0C2340"/>
-                      </a:solidFill>
-                      <a:prstDash val="solid"/>
-                      <a:round/>
-                      <a:headEnd type="none" w="med" len="med"/>
-                      <a:tailEnd type="none" w="med" len="med"/>
-                    </a:lnB>
-                  </a:tcPr>
-                </a:tc>
-              </a:tr>
-              <a:tr h="292608">
-                <a:tc>
-                  <a:txBody>
-                    <a:bodyPr/>
-                    <a:lstStyle/>
-                    <a:p>
-                      <a:pPr algn="l" indent="0" marL="0">
-                        <a:buNone/>
-                      </a:pPr>
-                      <a:r>
-                        <a:rPr lang="en-US" sz="900" b="1" dirty="0">
-                          <a:solidFill>
-                            <a:srgbClr val="222222"/>
-                          </a:solidFill>
-                          <a:latin typeface="Calibri" pitchFamily="34" charset="0"/>
-                          <a:ea typeface="Calibri" pitchFamily="34" charset="-122"/>
-                          <a:cs typeface="Calibri" pitchFamily="34" charset="-120"/>
-                        </a:rPr>
-                        <a:t>Electrolyzer capacity (GW)</a:t>
-                      </a:r>
-                      <a:endParaRPr lang="en-US" sz="900" dirty="0">
-                        <a:latin typeface="Calibri" charset="0"/>
-                        <a:ea typeface="Calibri" charset="0"/>
-                        <a:cs typeface="Calibri" charset="0"/>
-                      </a:endParaRPr>
-                    </a:p>
-                  </a:txBody>
-                  <a:tcPr marL="50800" marR="50800" marT="25400" marB="25400">
-                    <a:lnL w="0" cap="flat" cmpd="sng" algn="ctr">
-                      <a:solidFill>
-                        <a:srgbClr val="FFFFFF"/>
-                      </a:solidFill>
-                      <a:prstDash val="solid"/>
-                      <a:round/>
-                      <a:headEnd type="none" w="med" len="med"/>
-                      <a:tailEnd type="none" w="med" len="med"/>
-                    </a:lnL>
-                    <a:lnR w="0" cap="flat" cmpd="sng" algn="ctr">
-                      <a:solidFill>
-                        <a:srgbClr val="FFFFFF"/>
-                      </a:solidFill>
-                      <a:prstDash val="solid"/>
-                      <a:round/>
-                      <a:headEnd type="none" w="med" len="med"/>
-                      <a:tailEnd type="none" w="med" len="med"/>
-                    </a:lnR>
-                    <a:lnT w="0" cap="flat" cmpd="sng" algn="ctr">
-                      <a:solidFill>
-                        <a:srgbClr val="FFFFFF"/>
+                    <a:lnT w="6350" cap="flat" cmpd="sng" algn="ctr">
+                      <a:solidFill>
+                        <a:srgbClr val="D0D0D0"/>
                       </a:solidFill>
                       <a:prstDash val="solid"/>
                       <a:round/>
@@ -2306,13 +1685,16 @@
                     </a:lnT>
                     <a:lnB w="6350" cap="flat" cmpd="sng" algn="ctr">
                       <a:solidFill>
-                        <a:srgbClr val="E8E8E8"/>
+                        <a:srgbClr val="D0D0D0"/>
                       </a:solidFill>
                       <a:prstDash val="solid"/>
                       <a:round/>
                       <a:headEnd type="none" w="med" len="med"/>
                       <a:tailEnd type="none" w="med" len="med"/>
                     </a:lnB>
+                    <a:solidFill>
+                      <a:srgbClr val="FFFFFF"/>
+                    </a:solidFill>
                   </a:tcPr>
                 </a:tc>
                 <a:tc>
@@ -2320,28 +1702,70 @@
                     <a:bodyPr/>
                     <a:lstStyle/>
                     <a:p>
-                      <a:pPr algn="ctr" indent="0" marL="0">
-                        <a:buNone/>
-                      </a:pPr>
-                      <a:r>
-                        <a:rPr lang="en-US" sz="800" dirty="0">
-                          <a:solidFill>
-                            <a:srgbClr val="404040"/>
-                          </a:solidFill>
-                          <a:latin typeface="Calibri" pitchFamily="34" charset="0"/>
-                          <a:ea typeface="Calibri" pitchFamily="34" charset="-122"/>
-                          <a:cs typeface="Calibri" pitchFamily="34" charset="-120"/>
-                        </a:rPr>
-                        <a:t>~0.01</a:t>
-                      </a:r>
-                      <a:endParaRPr lang="en-US" sz="800" dirty="0">
+                      <a:pPr indent="0" marL="0">
+                        <a:buNone/>
+                      </a:pPr>
+                      <a:r>
+                        <a:rPr lang="en-US" sz="850" dirty="0">
+                          <a:solidFill>
+                            <a:srgbClr val="333333"/>
+                          </a:solidFill>
+                          <a:latin typeface="Calibri" pitchFamily="34" charset="0"/>
+                          <a:ea typeface="Calibri" pitchFamily="34" charset="-122"/>
+                          <a:cs typeface="Calibri" pitchFamily="34" charset="-120"/>
+                        </a:rPr>
+                        <a:t>Split water into H2 and O2 in an</a:t>
+                      </a:r>
+                      <a:endParaRPr lang="en-US" sz="850" dirty="0">
+                        <a:latin typeface="Calibri" charset="0"/>
+                        <a:ea typeface="Calibri" charset="0"/>
+                        <a:cs typeface="Calibri" charset="0"/>
+                      </a:endParaRPr>
+                    </a:p>
+                    <a:p>
+                      <a:pPr indent="0" marL="0">
+                        <a:buNone/>
+                      </a:pPr>
+                      <a:r>
+                        <a:rPr lang="en-US" sz="850" dirty="0">
+                          <a:solidFill>
+                            <a:srgbClr val="333333"/>
+                          </a:solidFill>
+                          <a:latin typeface="Calibri" pitchFamily="34" charset="0"/>
+                          <a:ea typeface="Calibri" pitchFamily="34" charset="-122"/>
+                          <a:cs typeface="Calibri" pitchFamily="34" charset="-120"/>
+                        </a:rPr>
+                        <a:t>electrolyzer that is powered</a:t>
+                      </a:r>
+                      <a:endParaRPr lang="en-US" sz="850" dirty="0">
+                        <a:latin typeface="Calibri" charset="0"/>
+                        <a:ea typeface="Calibri" charset="0"/>
+                        <a:cs typeface="Calibri" charset="0"/>
+                      </a:endParaRPr>
+                    </a:p>
+                    <a:p>
+                      <a:pPr indent="0" marL="0">
+                        <a:buNone/>
+                      </a:pPr>
+                      <a:r>
+                        <a:rPr lang="en-US" sz="850" dirty="0">
+                          <a:solidFill>
+                            <a:srgbClr val="333333"/>
+                          </a:solidFill>
+                          <a:latin typeface="Calibri" pitchFamily="34" charset="0"/>
+                          <a:ea typeface="Calibri" pitchFamily="34" charset="-122"/>
+                          <a:cs typeface="Calibri" pitchFamily="34" charset="-120"/>
+                        </a:rPr>
+                        <a:t>by renewables</a:t>
+                      </a:r>
+                      <a:endParaRPr lang="en-US" sz="850" dirty="0">
                         <a:latin typeface="Calibri" charset="0"/>
                         <a:ea typeface="Calibri" charset="0"/>
                         <a:cs typeface="Calibri" charset="0"/>
                       </a:endParaRPr>
                     </a:p>
                   </a:txBody>
-                  <a:tcPr marL="50800" marR="50800" marT="25400" marB="25400">
+                  <a:tcPr marL="91440" marR="91440" marT="45720" marB="45720" anchor="ctr">
                     <a:lnL w="0" cap="flat" cmpd="sng" algn="ctr">
                       <a:solidFill>
                         <a:srgbClr val="FFFFFF"/>
@@ -2360,9 +1784,9 @@
                       <a:headEnd type="none" w="med" len="med"/>
                       <a:tailEnd type="none" w="med" len="med"/>
                     </a:lnR>
-                    <a:lnT w="0" cap="flat" cmpd="sng" algn="ctr">
-                      <a:solidFill>
-                        <a:srgbClr val="FFFFFF"/>
+                    <a:lnT w="6350" cap="flat" cmpd="sng" algn="ctr">
+                      <a:solidFill>
+                        <a:srgbClr val="D0D0D0"/>
                       </a:solidFill>
                       <a:prstDash val="solid"/>
                       <a:round/>
@@ -2371,13 +1795,107 @@
                     </a:lnT>
                     <a:lnB w="6350" cap="flat" cmpd="sng" algn="ctr">
                       <a:solidFill>
-                        <a:srgbClr val="E8E8E8"/>
+                        <a:srgbClr val="D0D0D0"/>
                       </a:solidFill>
                       <a:prstDash val="solid"/>
                       <a:round/>
                       <a:headEnd type="none" w="med" len="med"/>
                       <a:tailEnd type="none" w="med" len="med"/>
                     </a:lnB>
+                    <a:solidFill>
+                      <a:srgbClr val="FFFFFF"/>
+                    </a:solidFill>
+                  </a:tcPr>
+                </a:tc>
+              </a:tr>
+              <a:tr h="384048">
+                <a:tc>
+                  <a:txBody>
+                    <a:bodyPr/>
+                    <a:lstStyle/>
+                    <a:p>
+                      <a:pPr indent="0" marL="0">
+                        <a:buNone/>
+                      </a:pPr>
+                      <a:r>
+                        <a:rPr lang="en-US" sz="850" b="1" dirty="0">
+                          <a:solidFill>
+                            <a:srgbClr val="000000"/>
+                          </a:solidFill>
+                          <a:latin typeface="Calibri" pitchFamily="34" charset="0"/>
+                          <a:ea typeface="Calibri" pitchFamily="34" charset="-122"/>
+                          <a:cs typeface="Calibri" pitchFamily="34" charset="-120"/>
+                        </a:rPr>
+                        <a:t>CO2 emissions</a:t>
+                      </a:r>
+                      <a:endParaRPr lang="en-US" sz="850" dirty="0">
+                        <a:latin typeface="Calibri" charset="0"/>
+                        <a:ea typeface="Calibri" charset="0"/>
+                        <a:cs typeface="Calibri" charset="0"/>
+                      </a:endParaRPr>
+                    </a:p>
+                    <a:p>
+                      <a:pPr indent="0" marL="0">
+                        <a:buNone/>
+                      </a:pPr>
+                      <a:r>
+                        <a:rPr lang="en-US" sz="850" b="1" dirty="0">
+                          <a:solidFill>
+                            <a:srgbClr val="000000"/>
+                          </a:solidFill>
+                          <a:latin typeface="Calibri" pitchFamily="34" charset="0"/>
+                          <a:ea typeface="Calibri" pitchFamily="34" charset="-122"/>
+                          <a:cs typeface="Calibri" pitchFamily="34" charset="-120"/>
+                        </a:rPr>
+                        <a:t>kg CO2/kgH2</a:t>
+                      </a:r>
+                      <a:endParaRPr lang="en-US" sz="850" dirty="0">
+                        <a:latin typeface="Calibri" charset="0"/>
+                        <a:ea typeface="Calibri" charset="0"/>
+                        <a:cs typeface="Calibri" charset="0"/>
+                      </a:endParaRPr>
+                    </a:p>
+                  </a:txBody>
+                  <a:tcPr marL="91440" marR="91440" marT="45720" marB="45720" anchor="ctr">
+                    <a:lnL w="0" cap="flat" cmpd="sng" algn="ctr">
+                      <a:solidFill>
+                        <a:srgbClr val="FFFFFF"/>
+                      </a:solidFill>
+                      <a:prstDash val="solid"/>
+                      <a:round/>
+                      <a:headEnd type="none" w="med" len="med"/>
+                      <a:tailEnd type="none" w="med" len="med"/>
+                    </a:lnL>
+                    <a:lnR w="0" cap="flat" cmpd="sng" algn="ctr">
+                      <a:solidFill>
+                        <a:srgbClr val="FFFFFF"/>
+                      </a:solidFill>
+                      <a:prstDash val="solid"/>
+                      <a:round/>
+                      <a:headEnd type="none" w="med" len="med"/>
+                      <a:tailEnd type="none" w="med" len="med"/>
+                    </a:lnR>
+                    <a:lnT w="6350" cap="flat" cmpd="sng" algn="ctr">
+                      <a:solidFill>
+                        <a:srgbClr val="D0D0D0"/>
+                      </a:solidFill>
+                      <a:prstDash val="solid"/>
+                      <a:round/>
+                      <a:headEnd type="none" w="med" len="med"/>
+                      <a:tailEnd type="none" w="med" len="med"/>
+                    </a:lnT>
+                    <a:lnB w="6350" cap="flat" cmpd="sng" algn="ctr">
+                      <a:solidFill>
+                        <a:srgbClr val="D0D0D0"/>
+                      </a:solidFill>
+                      <a:prstDash val="solid"/>
+                      <a:round/>
+                      <a:headEnd type="none" w="med" len="med"/>
+                      <a:tailEnd type="none" w="med" len="med"/>
+                    </a:lnB>
+                    <a:solidFill>
+                      <a:srgbClr val="FFFFFF"/>
+                    </a:solidFill>
                   </a:tcPr>
                 </a:tc>
                 <a:tc>
@@ -2385,28 +1903,28 @@
                     <a:bodyPr/>
                     <a:lstStyle/>
                     <a:p>
-                      <a:pPr algn="ctr" indent="0" marL="0">
-                        <a:buNone/>
-                      </a:pPr>
-                      <a:r>
-                        <a:rPr lang="en-US" sz="800" dirty="0">
-                          <a:solidFill>
-                            <a:srgbClr val="404040"/>
-                          </a:solidFill>
-                          <a:latin typeface="Calibri" pitchFamily="34" charset="0"/>
-                          <a:ea typeface="Calibri" pitchFamily="34" charset="-122"/>
-                          <a:cs typeface="Calibri" pitchFamily="34" charset="-120"/>
-                        </a:rPr>
-                        <a:t>0.5</a:t>
-                      </a:r>
-                      <a:endParaRPr lang="en-US" sz="800" dirty="0">
+                      <a:pPr indent="0" marL="0">
+                        <a:buNone/>
+                      </a:pPr>
+                      <a:r>
+                        <a:rPr lang="en-US" sz="850" dirty="0">
+                          <a:solidFill>
+                            <a:srgbClr val="333333"/>
+                          </a:solidFill>
+                          <a:latin typeface="Calibri" pitchFamily="34" charset="0"/>
+                          <a:ea typeface="Calibri" pitchFamily="34" charset="-122"/>
+                          <a:cs typeface="Calibri" pitchFamily="34" charset="-120"/>
+                        </a:rPr>
+                        <a:t>~10</a:t>
+                      </a:r>
+                      <a:endParaRPr lang="en-US" sz="850" dirty="0">
                         <a:latin typeface="Calibri" charset="0"/>
                         <a:ea typeface="Calibri" charset="0"/>
                         <a:cs typeface="Calibri" charset="0"/>
                       </a:endParaRPr>
                     </a:p>
                   </a:txBody>
-                  <a:tcPr marL="50800" marR="50800" marT="25400" marB="25400">
+                  <a:tcPr marL="91440" marR="91440" marT="45720" marB="45720" anchor="ctr">
                     <a:lnL w="0" cap="flat" cmpd="sng" algn="ctr">
                       <a:solidFill>
                         <a:srgbClr val="FFFFFF"/>
@@ -2425,9 +1943,9 @@
                       <a:headEnd type="none" w="med" len="med"/>
                       <a:tailEnd type="none" w="med" len="med"/>
                     </a:lnR>
-                    <a:lnT w="0" cap="flat" cmpd="sng" algn="ctr">
-                      <a:solidFill>
-                        <a:srgbClr val="FFFFFF"/>
+                    <a:lnT w="6350" cap="flat" cmpd="sng" algn="ctr">
+                      <a:solidFill>
+                        <a:srgbClr val="D0D0D0"/>
                       </a:solidFill>
                       <a:prstDash val="solid"/>
                       <a:round/>
@@ -2436,13 +1954,16 @@
                     </a:lnT>
                     <a:lnB w="6350" cap="flat" cmpd="sng" algn="ctr">
                       <a:solidFill>
-                        <a:srgbClr val="E8E8E8"/>
+                        <a:srgbClr val="D0D0D0"/>
                       </a:solidFill>
                       <a:prstDash val="solid"/>
                       <a:round/>
                       <a:headEnd type="none" w="med" len="med"/>
                       <a:tailEnd type="none" w="med" len="med"/>
                     </a:lnB>
+                    <a:solidFill>
+                      <a:srgbClr val="FFFFFF"/>
+                    </a:solidFill>
                   </a:tcPr>
                 </a:tc>
                 <a:tc>
@@ -2450,28 +1971,49 @@
                     <a:bodyPr/>
                     <a:lstStyle/>
                     <a:p>
-                      <a:pPr algn="ctr" indent="0" marL="0">
-                        <a:buNone/>
-                      </a:pPr>
-                      <a:r>
-                        <a:rPr lang="en-US" sz="800" dirty="0">
-                          <a:solidFill>
-                            <a:srgbClr val="404040"/>
-                          </a:solidFill>
-                          <a:latin typeface="Calibri" pitchFamily="34" charset="0"/>
-                          <a:ea typeface="Calibri" pitchFamily="34" charset="-122"/>
-                          <a:cs typeface="Calibri" pitchFamily="34" charset="-120"/>
-                        </a:rPr>
-                        <a:t>2.0</a:t>
-                      </a:r>
-                      <a:endParaRPr lang="en-US" sz="800" dirty="0">
+                      <a:pPr indent="0" marL="0">
+                        <a:buNone/>
+                      </a:pPr>
+                      <a:r>
+                        <a:rPr lang="en-US" sz="850" dirty="0">
+                          <a:solidFill>
+                            <a:srgbClr val="333333"/>
+                          </a:solidFill>
+                          <a:latin typeface="Calibri" pitchFamily="34" charset="0"/>
+                          <a:ea typeface="Calibri" pitchFamily="34" charset="-122"/>
+                          <a:cs typeface="Calibri" pitchFamily="34" charset="-120"/>
+                        </a:rPr>
+                        <a:t>~1-3</a:t>
+                      </a:r>
+                      <a:endParaRPr lang="en-US" sz="850" dirty="0">
+                        <a:latin typeface="Calibri" charset="0"/>
+                        <a:ea typeface="Calibri" charset="0"/>
+                        <a:cs typeface="Calibri" charset="0"/>
+                      </a:endParaRPr>
+                    </a:p>
+                    <a:p>
+                      <a:pPr indent="0" marL="0">
+                        <a:buNone/>
+                      </a:pPr>
+                      <a:r>
+                        <a:rPr lang="en-US" sz="850" dirty="0">
+                          <a:solidFill>
+                            <a:srgbClr val="333333"/>
+                          </a:solidFill>
+                          <a:latin typeface="Calibri" pitchFamily="34" charset="0"/>
+                          <a:ea typeface="Calibri" pitchFamily="34" charset="-122"/>
+                          <a:cs typeface="Calibri" pitchFamily="34" charset="-120"/>
+                        </a:rPr>
+                        <a:t>Most CO2 stored</a:t>
+                      </a:r>
+                      <a:endParaRPr lang="en-US" sz="850" dirty="0">
                         <a:latin typeface="Calibri" charset="0"/>
                         <a:ea typeface="Calibri" charset="0"/>
                         <a:cs typeface="Calibri" charset="0"/>
                       </a:endParaRPr>
                     </a:p>
                   </a:txBody>
-                  <a:tcPr marL="50800" marR="50800" marT="25400" marB="25400">
+                  <a:tcPr marL="91440" marR="91440" marT="45720" marB="45720" anchor="ctr">
                     <a:lnL w="0" cap="flat" cmpd="sng" algn="ctr">
                       <a:solidFill>
                         <a:srgbClr val="FFFFFF"/>
@@ -2490,9 +2032,9 @@
                       <a:headEnd type="none" w="med" len="med"/>
                       <a:tailEnd type="none" w="med" len="med"/>
                     </a:lnR>
-                    <a:lnT w="0" cap="flat" cmpd="sng" algn="ctr">
-                      <a:solidFill>
-                        <a:srgbClr val="FFFFFF"/>
+                    <a:lnT w="6350" cap="flat" cmpd="sng" algn="ctr">
+                      <a:solidFill>
+                        <a:srgbClr val="D0D0D0"/>
                       </a:solidFill>
                       <a:prstDash val="solid"/>
                       <a:round/>
@@ -2501,13 +2043,16 @@
                     </a:lnT>
                     <a:lnB w="6350" cap="flat" cmpd="sng" algn="ctr">
                       <a:solidFill>
-                        <a:srgbClr val="E8E8E8"/>
+                        <a:srgbClr val="D0D0D0"/>
                       </a:solidFill>
                       <a:prstDash val="solid"/>
                       <a:round/>
                       <a:headEnd type="none" w="med" len="med"/>
                       <a:tailEnd type="none" w="med" len="med"/>
                     </a:lnB>
+                    <a:solidFill>
+                      <a:srgbClr val="FFFFFF"/>
+                    </a:solidFill>
                   </a:tcPr>
                 </a:tc>
                 <a:tc>
@@ -2515,28 +2060,49 @@
                     <a:bodyPr/>
                     <a:lstStyle/>
                     <a:p>
-                      <a:pPr algn="ctr" indent="0" marL="0">
-                        <a:buNone/>
-                      </a:pPr>
-                      <a:r>
-                        <a:rPr lang="en-US" sz="800" dirty="0">
-                          <a:solidFill>
-                            <a:srgbClr val="404040"/>
-                          </a:solidFill>
-                          <a:latin typeface="Calibri" pitchFamily="34" charset="0"/>
-                          <a:ea typeface="Calibri" pitchFamily="34" charset="-122"/>
-                          <a:cs typeface="Calibri" pitchFamily="34" charset="-120"/>
-                        </a:rPr>
-                        <a:t>3–4</a:t>
-                      </a:r>
-                      <a:endParaRPr lang="en-US" sz="800" dirty="0">
+                      <a:pPr indent="0" marL="0">
+                        <a:buNone/>
+                      </a:pPr>
+                      <a:r>
+                        <a:rPr lang="en-US" sz="850" dirty="0">
+                          <a:solidFill>
+                            <a:srgbClr val="333333"/>
+                          </a:solidFill>
+                          <a:latin typeface="Calibri" pitchFamily="34" charset="0"/>
+                          <a:ea typeface="Calibri" pitchFamily="34" charset="-122"/>
+                          <a:cs typeface="Calibri" pitchFamily="34" charset="-120"/>
+                        </a:rPr>
+                        <a:t>~0</a:t>
+                      </a:r>
+                      <a:endParaRPr lang="en-US" sz="850" dirty="0">
+                        <a:latin typeface="Calibri" charset="0"/>
+                        <a:ea typeface="Calibri" charset="0"/>
+                        <a:cs typeface="Calibri" charset="0"/>
+                      </a:endParaRPr>
+                    </a:p>
+                    <a:p>
+                      <a:pPr indent="0" marL="0">
+                        <a:buNone/>
+                      </a:pPr>
+                      <a:r>
+                        <a:rPr lang="en-US" sz="850" dirty="0">
+                          <a:solidFill>
+                            <a:srgbClr val="333333"/>
+                          </a:solidFill>
+                          <a:latin typeface="Calibri" pitchFamily="34" charset="0"/>
+                          <a:ea typeface="Calibri" pitchFamily="34" charset="-122"/>
+                          <a:cs typeface="Calibri" pitchFamily="34" charset="-120"/>
+                        </a:rPr>
+                        <a:t>Assuming Green electricity mix²</a:t>
+                      </a:r>
+                      <a:endParaRPr lang="en-US" sz="850" dirty="0">
                         <a:latin typeface="Calibri" charset="0"/>
                         <a:ea typeface="Calibri" charset="0"/>
                         <a:cs typeface="Calibri" charset="0"/>
                       </a:endParaRPr>
                     </a:p>
                   </a:txBody>
-                  <a:tcPr marL="50800" marR="50800" marT="25400" marB="25400">
+                  <a:tcPr marL="91440" marR="91440" marT="45720" marB="45720" anchor="ctr">
                     <a:lnL w="0" cap="flat" cmpd="sng" algn="ctr">
                       <a:solidFill>
                         <a:srgbClr val="FFFFFF"/>
@@ -2555,9 +2121,9 @@
                       <a:headEnd type="none" w="med" len="med"/>
                       <a:tailEnd type="none" w="med" len="med"/>
                     </a:lnR>
-                    <a:lnT w="0" cap="flat" cmpd="sng" algn="ctr">
-                      <a:solidFill>
-                        <a:srgbClr val="FFFFFF"/>
+                    <a:lnT w="6350" cap="flat" cmpd="sng" algn="ctr">
+                      <a:solidFill>
+                        <a:srgbClr val="D0D0D0"/>
                       </a:solidFill>
                       <a:prstDash val="solid"/>
                       <a:round/>
@@ -2566,13 +2132,107 @@
                     </a:lnT>
                     <a:lnB w="6350" cap="flat" cmpd="sng" algn="ctr">
                       <a:solidFill>
-                        <a:srgbClr val="E8E8E8"/>
+                        <a:srgbClr val="D0D0D0"/>
                       </a:solidFill>
                       <a:prstDash val="solid"/>
                       <a:round/>
                       <a:headEnd type="none" w="med" len="med"/>
                       <a:tailEnd type="none" w="med" len="med"/>
                     </a:lnB>
+                    <a:solidFill>
+                      <a:srgbClr val="FFFFFF"/>
+                    </a:solidFill>
+                  </a:tcPr>
+                </a:tc>
+              </a:tr>
+              <a:tr h="621792">
+                <a:tc>
+                  <a:txBody>
+                    <a:bodyPr/>
+                    <a:lstStyle/>
+                    <a:p>
+                      <a:pPr indent="0" marL="0">
+                        <a:buNone/>
+                      </a:pPr>
+                      <a:r>
+                        <a:rPr lang="en-US" sz="850" b="1" dirty="0">
+                          <a:solidFill>
+                            <a:srgbClr val="000000"/>
+                          </a:solidFill>
+                          <a:latin typeface="Calibri" pitchFamily="34" charset="0"/>
+                          <a:ea typeface="Calibri" pitchFamily="34" charset="-122"/>
+                          <a:cs typeface="Calibri" pitchFamily="34" charset="-120"/>
+                        </a:rPr>
+                        <a:t>Investments</a:t>
+                      </a:r>
+                      <a:endParaRPr lang="en-US" sz="850" dirty="0">
+                        <a:latin typeface="Calibri" charset="0"/>
+                        <a:ea typeface="Calibri" charset="0"/>
+                        <a:cs typeface="Calibri" charset="0"/>
+                      </a:endParaRPr>
+                    </a:p>
+                    <a:p>
+                      <a:pPr indent="0" marL="0">
+                        <a:buNone/>
+                      </a:pPr>
+                      <a:r>
+                        <a:rPr lang="en-US" sz="850" b="1" dirty="0">
+                          <a:solidFill>
+                            <a:srgbClr val="000000"/>
+                          </a:solidFill>
+                          <a:latin typeface="Calibri" pitchFamily="34" charset="0"/>
+                          <a:ea typeface="Calibri" pitchFamily="34" charset="-122"/>
+                          <a:cs typeface="Calibri" pitchFamily="34" charset="-120"/>
+                        </a:rPr>
+                        <a:t>and complexity</a:t>
+                      </a:r>
+                      <a:endParaRPr lang="en-US" sz="850" dirty="0">
+                        <a:latin typeface="Calibri" charset="0"/>
+                        <a:ea typeface="Calibri" charset="0"/>
+                        <a:cs typeface="Calibri" charset="0"/>
+                      </a:endParaRPr>
+                    </a:p>
+                  </a:txBody>
+                  <a:tcPr marL="91440" marR="91440" marT="45720" marB="45720" anchor="ctr">
+                    <a:lnL w="0" cap="flat" cmpd="sng" algn="ctr">
+                      <a:solidFill>
+                        <a:srgbClr val="FFFFFF"/>
+                      </a:solidFill>
+                      <a:prstDash val="solid"/>
+                      <a:round/>
+                      <a:headEnd type="none" w="med" len="med"/>
+                      <a:tailEnd type="none" w="med" len="med"/>
+                    </a:lnL>
+                    <a:lnR w="0" cap="flat" cmpd="sng" algn="ctr">
+                      <a:solidFill>
+                        <a:srgbClr val="FFFFFF"/>
+                      </a:solidFill>
+                      <a:prstDash val="solid"/>
+                      <a:round/>
+                      <a:headEnd type="none" w="med" len="med"/>
+                      <a:tailEnd type="none" w="med" len="med"/>
+                    </a:lnR>
+                    <a:lnT w="6350" cap="flat" cmpd="sng" algn="ctr">
+                      <a:solidFill>
+                        <a:srgbClr val="D0D0D0"/>
+                      </a:solidFill>
+                      <a:prstDash val="solid"/>
+                      <a:round/>
+                      <a:headEnd type="none" w="med" len="med"/>
+                      <a:tailEnd type="none" w="med" len="med"/>
+                    </a:lnT>
+                    <a:lnB w="6350" cap="flat" cmpd="sng" algn="ctr">
+                      <a:solidFill>
+                        <a:srgbClr val="D0D0D0"/>
+                      </a:solidFill>
+                      <a:prstDash val="solid"/>
+                      <a:round/>
+                      <a:headEnd type="none" w="med" len="med"/>
+                      <a:tailEnd type="none" w="med" len="med"/>
+                    </a:lnB>
+                    <a:solidFill>
+                      <a:srgbClr val="FFFFFF"/>
+                    </a:solidFill>
                   </a:tcPr>
                 </a:tc>
                 <a:tc>
@@ -2580,28 +2240,70 @@
                     <a:bodyPr/>
                     <a:lstStyle/>
                     <a:p>
-                      <a:pPr algn="ctr" indent="0" marL="0">
-                        <a:buNone/>
-                      </a:pPr>
-                      <a:r>
-                        <a:rPr lang="en-US" sz="800" dirty="0">
-                          <a:solidFill>
-                            <a:srgbClr val="404040"/>
-                          </a:solidFill>
-                          <a:latin typeface="Calibri" pitchFamily="34" charset="0"/>
-                          <a:ea typeface="Calibri" pitchFamily="34" charset="-122"/>
-                          <a:cs typeface="Calibri" pitchFamily="34" charset="-120"/>
-                        </a:rPr>
-                        <a:t>8+</a:t>
-                      </a:r>
-                      <a:endParaRPr lang="en-US" sz="800" dirty="0">
+                      <a:pPr indent="0" marL="0">
+                        <a:buNone/>
+                      </a:pPr>
+                      <a:r>
+                        <a:rPr lang="en-US" sz="850" dirty="0">
+                          <a:solidFill>
+                            <a:srgbClr val="333333"/>
+                          </a:solidFill>
+                          <a:latin typeface="Calibri" pitchFamily="34" charset="0"/>
+                          <a:ea typeface="Calibri" pitchFamily="34" charset="-122"/>
+                          <a:cs typeface="Calibri" pitchFamily="34" charset="-120"/>
+                        </a:rPr>
+                        <a:t>Large scale, one-off facilities</a:t>
+                      </a:r>
+                      <a:endParaRPr lang="en-US" sz="850" dirty="0">
+                        <a:latin typeface="Calibri" charset="0"/>
+                        <a:ea typeface="Calibri" charset="0"/>
+                        <a:cs typeface="Calibri" charset="0"/>
+                      </a:endParaRPr>
+                    </a:p>
+                    <a:p>
+                      <a:pPr indent="0" marL="0">
+                        <a:buNone/>
+                      </a:pPr>
+                      <a:r>
+                        <a:rPr lang="en-US" sz="850" dirty="0">
+                          <a:solidFill>
+                            <a:srgbClr val="333333"/>
+                          </a:solidFill>
+                          <a:latin typeface="Calibri" pitchFamily="34" charset="0"/>
+                          <a:ea typeface="Calibri" pitchFamily="34" charset="-122"/>
+                          <a:cs typeface="Calibri" pitchFamily="34" charset="-120"/>
+                        </a:rPr>
+                        <a:t>Requiring triple-digit million</a:t>
+                      </a:r>
+                      <a:endParaRPr lang="en-US" sz="850" dirty="0">
+                        <a:latin typeface="Calibri" charset="0"/>
+                        <a:ea typeface="Calibri" charset="0"/>
+                        <a:cs typeface="Calibri" charset="0"/>
+                      </a:endParaRPr>
+                    </a:p>
+                    <a:p>
+                      <a:pPr indent="0" marL="0">
+                        <a:buNone/>
+                      </a:pPr>
+                      <a:r>
+                        <a:rPr lang="en-US" sz="850" dirty="0">
+                          <a:solidFill>
+                            <a:srgbClr val="333333"/>
+                          </a:solidFill>
+                          <a:latin typeface="Calibri" pitchFamily="34" charset="0"/>
+                          <a:ea typeface="Calibri" pitchFamily="34" charset="-122"/>
+                          <a:cs typeface="Calibri" pitchFamily="34" charset="-120"/>
+                        </a:rPr>
+                        <a:t>EUR CAPEX per facility</a:t>
+                      </a:r>
+                      <a:endParaRPr lang="en-US" sz="850" dirty="0">
                         <a:latin typeface="Calibri" charset="0"/>
                         <a:ea typeface="Calibri" charset="0"/>
                         <a:cs typeface="Calibri" charset="0"/>
                       </a:endParaRPr>
                     </a:p>
                   </a:txBody>
-                  <a:tcPr marL="50800" marR="50800" marT="25400" marB="25400">
+                  <a:tcPr marL="91440" marR="91440" marT="45720" marB="45720" anchor="ctr">
                     <a:lnL w="0" cap="flat" cmpd="sng" algn="ctr">
                       <a:solidFill>
                         <a:srgbClr val="FFFFFF"/>
@@ -2620,9 +2322,9 @@
                       <a:headEnd type="none" w="med" len="med"/>
                       <a:tailEnd type="none" w="med" len="med"/>
                     </a:lnR>
-                    <a:lnT w="0" cap="flat" cmpd="sng" algn="ctr">
-                      <a:solidFill>
-                        <a:srgbClr val="FFFFFF"/>
+                    <a:lnT w="6350" cap="flat" cmpd="sng" algn="ctr">
+                      <a:solidFill>
+                        <a:srgbClr val="D0D0D0"/>
                       </a:solidFill>
                       <a:prstDash val="solid"/>
                       <a:round/>
@@ -2631,80 +2333,16 @@
                     </a:lnT>
                     <a:lnB w="6350" cap="flat" cmpd="sng" algn="ctr">
                       <a:solidFill>
-                        <a:srgbClr val="E8E8E8"/>
+                        <a:srgbClr val="D0D0D0"/>
                       </a:solidFill>
                       <a:prstDash val="solid"/>
                       <a:round/>
                       <a:headEnd type="none" w="med" len="med"/>
                       <a:tailEnd type="none" w="med" len="med"/>
                     </a:lnB>
-                  </a:tcPr>
-                </a:tc>
-              </a:tr>
-              <a:tr h="292608">
-                <a:tc>
-                  <a:txBody>
-                    <a:bodyPr/>
-                    <a:lstStyle/>
-                    <a:p>
-                      <a:pPr algn="l" indent="0" marL="0">
-                        <a:buNone/>
-                      </a:pPr>
-                      <a:r>
-                        <a:rPr lang="en-US" sz="900" b="1" dirty="0">
-                          <a:solidFill>
-                            <a:srgbClr val="222222"/>
-                          </a:solidFill>
-                          <a:latin typeface="Calibri" pitchFamily="34" charset="0"/>
-                          <a:ea typeface="Calibri" pitchFamily="34" charset="-122"/>
-                          <a:cs typeface="Calibri" pitchFamily="34" charset="-120"/>
-                        </a:rPr>
-                        <a:t>Green H2 production (kt/yr)</a:t>
-                      </a:r>
-                      <a:endParaRPr lang="en-US" sz="900" dirty="0">
-                        <a:latin typeface="Calibri" charset="0"/>
-                        <a:ea typeface="Calibri" charset="0"/>
-                        <a:cs typeface="Calibri" charset="0"/>
-                      </a:endParaRPr>
-                    </a:p>
-                  </a:txBody>
-                  <a:tcPr marL="50800" marR="50800" marT="25400" marB="25400">
-                    <a:lnL w="0" cap="flat" cmpd="sng" algn="ctr">
-                      <a:solidFill>
-                        <a:srgbClr val="FFFFFF"/>
-                      </a:solidFill>
-                      <a:prstDash val="solid"/>
-                      <a:round/>
-                      <a:headEnd type="none" w="med" len="med"/>
-                      <a:tailEnd type="none" w="med" len="med"/>
-                    </a:lnL>
-                    <a:lnR w="0" cap="flat" cmpd="sng" algn="ctr">
-                      <a:solidFill>
-                        <a:srgbClr val="FFFFFF"/>
-                      </a:solidFill>
-                      <a:prstDash val="solid"/>
-                      <a:round/>
-                      <a:headEnd type="none" w="med" len="med"/>
-                      <a:tailEnd type="none" w="med" len="med"/>
-                    </a:lnR>
-                    <a:lnT w="0" cap="flat" cmpd="sng" algn="ctr">
-                      <a:solidFill>
-                        <a:srgbClr val="FFFFFF"/>
-                      </a:solidFill>
-                      <a:prstDash val="solid"/>
-                      <a:round/>
-                      <a:headEnd type="none" w="med" len="med"/>
-                      <a:tailEnd type="none" w="med" len="med"/>
-                    </a:lnT>
-                    <a:lnB w="6350" cap="flat" cmpd="sng" algn="ctr">
-                      <a:solidFill>
-                        <a:srgbClr val="E8E8E8"/>
-                      </a:solidFill>
-                      <a:prstDash val="solid"/>
-                      <a:round/>
-                      <a:headEnd type="none" w="med" len="med"/>
-                      <a:tailEnd type="none" w="med" len="med"/>
-                    </a:lnB>
+                    <a:solidFill>
+                      <a:srgbClr val="FFFFFF"/>
+                    </a:solidFill>
                   </a:tcPr>
                 </a:tc>
                 <a:tc>
@@ -2712,28 +2350,70 @@
                     <a:bodyPr/>
                     <a:lstStyle/>
                     <a:p>
-                      <a:pPr algn="ctr" indent="0" marL="0">
-                        <a:buNone/>
-                      </a:pPr>
-                      <a:r>
-                        <a:rPr lang="en-US" sz="800" dirty="0">
-                          <a:solidFill>
-                            <a:srgbClr val="404040"/>
-                          </a:solidFill>
-                          <a:latin typeface="Calibri" pitchFamily="34" charset="0"/>
-                          <a:ea typeface="Calibri" pitchFamily="34" charset="-122"/>
-                          <a:cs typeface="Calibri" pitchFamily="34" charset="-120"/>
-                        </a:rPr>
-                        <a:t>&lt;1</a:t>
-                      </a:r>
-                      <a:endParaRPr lang="en-US" sz="800" dirty="0">
+                      <a:pPr indent="0" marL="0">
+                        <a:buNone/>
+                      </a:pPr>
+                      <a:r>
+                        <a:rPr lang="en-US" sz="850" dirty="0">
+                          <a:solidFill>
+                            <a:srgbClr val="333333"/>
+                          </a:solidFill>
+                          <a:latin typeface="Calibri" pitchFamily="34" charset="0"/>
+                          <a:ea typeface="Calibri" pitchFamily="34" charset="-122"/>
+                          <a:cs typeface="Calibri" pitchFamily="34" charset="-120"/>
+                        </a:rPr>
+                        <a:t>Large scale and one-off facilities</a:t>
+                      </a:r>
+                      <a:endParaRPr lang="en-US" sz="850" dirty="0">
+                        <a:latin typeface="Calibri" charset="0"/>
+                        <a:ea typeface="Calibri" charset="0"/>
+                        <a:cs typeface="Calibri" charset="0"/>
+                      </a:endParaRPr>
+                    </a:p>
+                    <a:p>
+                      <a:pPr indent="0" marL="0">
+                        <a:buNone/>
+                      </a:pPr>
+                      <a:r>
+                        <a:rPr lang="en-US" sz="850" dirty="0">
+                          <a:solidFill>
+                            <a:srgbClr val="333333"/>
+                          </a:solidFill>
+                          <a:latin typeface="Calibri" pitchFamily="34" charset="0"/>
+                          <a:ea typeface="Calibri" pitchFamily="34" charset="-122"/>
+                          <a:cs typeface="Calibri" pitchFamily="34" charset="-120"/>
+                        </a:rPr>
+                        <a:t>Requiring triple-digit mn EUR</a:t>
+                      </a:r>
+                      <a:endParaRPr lang="en-US" sz="850" dirty="0">
+                        <a:latin typeface="Calibri" charset="0"/>
+                        <a:ea typeface="Calibri" charset="0"/>
+                        <a:cs typeface="Calibri" charset="0"/>
+                      </a:endParaRPr>
+                    </a:p>
+                    <a:p>
+                      <a:pPr indent="0" marL="0">
+                        <a:buNone/>
+                      </a:pPr>
+                      <a:r>
+                        <a:rPr lang="en-US" sz="850" dirty="0">
+                          <a:solidFill>
+                            <a:srgbClr val="333333"/>
+                          </a:solidFill>
+                          <a:latin typeface="Calibri" pitchFamily="34" charset="0"/>
+                          <a:ea typeface="Calibri" pitchFamily="34" charset="-122"/>
+                          <a:cs typeface="Calibri" pitchFamily="34" charset="-120"/>
+                        </a:rPr>
+                        <a:t>CAPEX per facility</a:t>
+                      </a:r>
+                      <a:endParaRPr lang="en-US" sz="850" dirty="0">
                         <a:latin typeface="Calibri" charset="0"/>
                         <a:ea typeface="Calibri" charset="0"/>
                         <a:cs typeface="Calibri" charset="0"/>
                       </a:endParaRPr>
                     </a:p>
                   </a:txBody>
-                  <a:tcPr marL="50800" marR="50800" marT="25400" marB="25400">
+                  <a:tcPr marL="91440" marR="91440" marT="45720" marB="45720" anchor="ctr">
                     <a:lnL w="0" cap="flat" cmpd="sng" algn="ctr">
                       <a:solidFill>
                         <a:srgbClr val="FFFFFF"/>
@@ -2752,9 +2432,9 @@
                       <a:headEnd type="none" w="med" len="med"/>
                       <a:tailEnd type="none" w="med" len="med"/>
                     </a:lnR>
-                    <a:lnT w="0" cap="flat" cmpd="sng" algn="ctr">
-                      <a:solidFill>
-                        <a:srgbClr val="FFFFFF"/>
+                    <a:lnT w="6350" cap="flat" cmpd="sng" algn="ctr">
+                      <a:solidFill>
+                        <a:srgbClr val="D0D0D0"/>
                       </a:solidFill>
                       <a:prstDash val="solid"/>
                       <a:round/>
@@ -2763,13 +2443,16 @@
                     </a:lnT>
                     <a:lnB w="6350" cap="flat" cmpd="sng" algn="ctr">
                       <a:solidFill>
-                        <a:srgbClr val="E8E8E8"/>
+                        <a:srgbClr val="D0D0D0"/>
                       </a:solidFill>
                       <a:prstDash val="solid"/>
                       <a:round/>
                       <a:headEnd type="none" w="med" len="med"/>
                       <a:tailEnd type="none" w="med" len="med"/>
                     </a:lnB>
+                    <a:solidFill>
+                      <a:srgbClr val="FFFFFF"/>
+                    </a:solidFill>
                   </a:tcPr>
                 </a:tc>
                 <a:tc>
@@ -2777,28 +2460,112 @@
                     <a:bodyPr/>
                     <a:lstStyle/>
                     <a:p>
-                      <a:pPr algn="ctr" indent="0" marL="0">
-                        <a:buNone/>
-                      </a:pPr>
-                      <a:r>
-                        <a:rPr lang="en-US" sz="800" dirty="0">
-                          <a:solidFill>
-                            <a:srgbClr val="404040"/>
-                          </a:solidFill>
-                          <a:latin typeface="Calibri" pitchFamily="34" charset="0"/>
-                          <a:ea typeface="Calibri" pitchFamily="34" charset="-122"/>
-                          <a:cs typeface="Calibri" pitchFamily="34" charset="-120"/>
-                        </a:rPr>
-                        <a:t>~50</a:t>
-                      </a:r>
-                      <a:endParaRPr lang="en-US" sz="800" dirty="0">
+                      <a:pPr indent="0" marL="0">
+                        <a:buNone/>
+                      </a:pPr>
+                      <a:r>
+                        <a:rPr lang="en-US" sz="850" dirty="0">
+                          <a:solidFill>
+                            <a:srgbClr val="333333"/>
+                          </a:solidFill>
+                          <a:latin typeface="Calibri" pitchFamily="34" charset="0"/>
+                          <a:ea typeface="Calibri" pitchFamily="34" charset="-122"/>
+                          <a:cs typeface="Calibri" pitchFamily="34" charset="-120"/>
+                        </a:rPr>
+                        <a:t>Small-scale (5-10MW) facilities</a:t>
+                      </a:r>
+                      <a:endParaRPr lang="en-US" sz="850" dirty="0">
+                        <a:latin typeface="Calibri" charset="0"/>
+                        <a:ea typeface="Calibri" charset="0"/>
+                        <a:cs typeface="Calibri" charset="0"/>
+                      </a:endParaRPr>
+                    </a:p>
+                    <a:p>
+                      <a:pPr indent="0" marL="0">
+                        <a:buNone/>
+                      </a:pPr>
+                      <a:r>
+                        <a:rPr lang="en-US" sz="850" dirty="0">
+                          <a:solidFill>
+                            <a:srgbClr val="333333"/>
+                          </a:solidFill>
+                          <a:latin typeface="Calibri" pitchFamily="34" charset="0"/>
+                          <a:ea typeface="Calibri" pitchFamily="34" charset="-122"/>
+                          <a:cs typeface="Calibri" pitchFamily="34" charset="-120"/>
+                        </a:rPr>
+                        <a:t>that can be replicated³</a:t>
+                      </a:r>
+                      <a:endParaRPr lang="en-US" sz="850" dirty="0">
+                        <a:latin typeface="Calibri" charset="0"/>
+                        <a:ea typeface="Calibri" charset="0"/>
+                        <a:cs typeface="Calibri" charset="0"/>
+                      </a:endParaRPr>
+                    </a:p>
+                    <a:p>
+                      <a:pPr indent="0" marL="0">
+                        <a:buNone/>
+                      </a:pPr>
+                      <a:r>
+                        <a:rPr lang="en-US" sz="850" dirty="0">
+                          <a:solidFill>
+                            <a:srgbClr val="333333"/>
+                          </a:solidFill>
+                          <a:latin typeface="Calibri" pitchFamily="34" charset="0"/>
+                          <a:ea typeface="Calibri" pitchFamily="34" charset="-122"/>
+                          <a:cs typeface="Calibri" pitchFamily="34" charset="-120"/>
+                        </a:rPr>
+                        <a:t>Single/double-digit mn EUR CAPEX</a:t>
+                      </a:r>
+                      <a:endParaRPr lang="en-US" sz="850" dirty="0">
+                        <a:latin typeface="Calibri" charset="0"/>
+                        <a:ea typeface="Calibri" charset="0"/>
+                        <a:cs typeface="Calibri" charset="0"/>
+                      </a:endParaRPr>
+                    </a:p>
+                    <a:p>
+                      <a:pPr indent="0" marL="0">
+                        <a:buNone/>
+                      </a:pPr>
+                      <a:r>
+                        <a:rPr lang="en-US" sz="850" dirty="0">
+                          <a:solidFill>
+                            <a:srgbClr val="333333"/>
+                          </a:solidFill>
+                          <a:latin typeface="Calibri" pitchFamily="34" charset="0"/>
+                          <a:ea typeface="Calibri" pitchFamily="34" charset="-122"/>
+                          <a:cs typeface="Calibri" pitchFamily="34" charset="-120"/>
+                        </a:rPr>
+                        <a:t>per facility, expecting 50-70%</a:t>
+                      </a:r>
+                      <a:endParaRPr lang="en-US" sz="850" dirty="0">
+                        <a:latin typeface="Calibri" charset="0"/>
+                        <a:ea typeface="Calibri" charset="0"/>
+                        <a:cs typeface="Calibri" charset="0"/>
+                      </a:endParaRPr>
+                    </a:p>
+                    <a:p>
+                      <a:pPr indent="0" marL="0">
+                        <a:buNone/>
+                      </a:pPr>
+                      <a:r>
+                        <a:rPr lang="en-US" sz="850" dirty="0">
+                          <a:solidFill>
+                            <a:srgbClr val="333333"/>
+                          </a:solidFill>
+                          <a:latin typeface="Calibri" pitchFamily="34" charset="0"/>
+                          <a:ea typeface="Calibri" pitchFamily="34" charset="-122"/>
+                          <a:cs typeface="Calibri" pitchFamily="34" charset="-120"/>
+                        </a:rPr>
+                        <a:t>reduction until 2030</a:t>
+                      </a:r>
+                      <a:endParaRPr lang="en-US" sz="850" dirty="0">
                         <a:latin typeface="Calibri" charset="0"/>
                         <a:ea typeface="Calibri" charset="0"/>
                         <a:cs typeface="Calibri" charset="0"/>
                       </a:endParaRPr>
                     </a:p>
                   </a:txBody>
-                  <a:tcPr marL="50800" marR="50800" marT="25400" marB="25400">
+                  <a:tcPr marL="91440" marR="91440" marT="45720" marB="45720" anchor="ctr">
                     <a:lnL w="0" cap="flat" cmpd="sng" algn="ctr">
                       <a:solidFill>
                         <a:srgbClr val="FFFFFF"/>
@@ -2817,9 +2584,9 @@
                       <a:headEnd type="none" w="med" len="med"/>
                       <a:tailEnd type="none" w="med" len="med"/>
                     </a:lnR>
-                    <a:lnT w="0" cap="flat" cmpd="sng" algn="ctr">
-                      <a:solidFill>
-                        <a:srgbClr val="FFFFFF"/>
+                    <a:lnT w="6350" cap="flat" cmpd="sng" algn="ctr">
+                      <a:solidFill>
+                        <a:srgbClr val="D0D0D0"/>
                       </a:solidFill>
                       <a:prstDash val="solid"/>
                       <a:round/>
@@ -2828,13 +2595,86 @@
                     </a:lnT>
                     <a:lnB w="6350" cap="flat" cmpd="sng" algn="ctr">
                       <a:solidFill>
-                        <a:srgbClr val="E8E8E8"/>
+                        <a:srgbClr val="D0D0D0"/>
                       </a:solidFill>
                       <a:prstDash val="solid"/>
                       <a:round/>
                       <a:headEnd type="none" w="med" len="med"/>
                       <a:tailEnd type="none" w="med" len="med"/>
                     </a:lnB>
+                    <a:solidFill>
+                      <a:srgbClr val="FFFFFF"/>
+                    </a:solidFill>
+                  </a:tcPr>
+                </a:tc>
+              </a:tr>
+              <a:tr h="384048">
+                <a:tc>
+                  <a:txBody>
+                    <a:bodyPr/>
+                    <a:lstStyle/>
+                    <a:p>
+                      <a:pPr indent="0" marL="0">
+                        <a:buNone/>
+                      </a:pPr>
+                      <a:r>
+                        <a:rPr lang="en-US" sz="850" b="1" dirty="0">
+                          <a:solidFill>
+                            <a:srgbClr val="000000"/>
+                          </a:solidFill>
+                          <a:latin typeface="Calibri" pitchFamily="34" charset="0"/>
+                          <a:ea typeface="Calibri" pitchFamily="34" charset="-122"/>
+                          <a:cs typeface="Calibri" pitchFamily="34" charset="-120"/>
+                        </a:rPr>
+                        <a:t>EPC duration</a:t>
+                      </a:r>
+                      <a:endParaRPr lang="en-US" sz="850" dirty="0">
+                        <a:latin typeface="Calibri" charset="0"/>
+                        <a:ea typeface="Calibri" charset="0"/>
+                        <a:cs typeface="Calibri" charset="0"/>
+                      </a:endParaRPr>
+                    </a:p>
+                  </a:txBody>
+                  <a:tcPr marL="91440" marR="91440" marT="45720" marB="45720" anchor="ctr">
+                    <a:lnL w="0" cap="flat" cmpd="sng" algn="ctr">
+                      <a:solidFill>
+                        <a:srgbClr val="FFFFFF"/>
+                      </a:solidFill>
+                      <a:prstDash val="solid"/>
+                      <a:round/>
+                      <a:headEnd type="none" w="med" len="med"/>
+                      <a:tailEnd type="none" w="med" len="med"/>
+                    </a:lnL>
+                    <a:lnR w="0" cap="flat" cmpd="sng" algn="ctr">
+                      <a:solidFill>
+                        <a:srgbClr val="FFFFFF"/>
+                      </a:solidFill>
+                      <a:prstDash val="solid"/>
+                      <a:round/>
+                      <a:headEnd type="none" w="med" len="med"/>
+                      <a:tailEnd type="none" w="med" len="med"/>
+                    </a:lnR>
+                    <a:lnT w="6350" cap="flat" cmpd="sng" algn="ctr">
+                      <a:solidFill>
+                        <a:srgbClr val="D0D0D0"/>
+                      </a:solidFill>
+                      <a:prstDash val="solid"/>
+                      <a:round/>
+                      <a:headEnd type="none" w="med" len="med"/>
+                      <a:tailEnd type="none" w="med" len="med"/>
+                    </a:lnT>
+                    <a:lnB w="6350" cap="flat" cmpd="sng" algn="ctr">
+                      <a:solidFill>
+                        <a:srgbClr val="D0D0D0"/>
+                      </a:solidFill>
+                      <a:prstDash val="solid"/>
+                      <a:round/>
+                      <a:headEnd type="none" w="med" len="med"/>
+                      <a:tailEnd type="none" w="med" len="med"/>
+                    </a:lnB>
+                    <a:solidFill>
+                      <a:srgbClr val="FFFFFF"/>
+                    </a:solidFill>
                   </a:tcPr>
                 </a:tc>
                 <a:tc>
@@ -2842,28 +2682,28 @@
                     <a:bodyPr/>
                     <a:lstStyle/>
                     <a:p>
-                      <a:pPr algn="ctr" indent="0" marL="0">
-                        <a:buNone/>
-                      </a:pPr>
-                      <a:r>
-                        <a:rPr lang="en-US" sz="800" dirty="0">
-                          <a:solidFill>
-                            <a:srgbClr val="404040"/>
-                          </a:solidFill>
-                          <a:latin typeface="Calibri" pitchFamily="34" charset="0"/>
-                          <a:ea typeface="Calibri" pitchFamily="34" charset="-122"/>
-                          <a:cs typeface="Calibri" pitchFamily="34" charset="-120"/>
-                        </a:rPr>
-                        <a:t>~200</a:t>
-                      </a:r>
-                      <a:endParaRPr lang="en-US" sz="800" dirty="0">
+                      <a:pPr indent="0" marL="0">
+                        <a:buNone/>
+                      </a:pPr>
+                      <a:r>
+                        <a:rPr lang="en-US" sz="850" dirty="0">
+                          <a:solidFill>
+                            <a:srgbClr val="333333"/>
+                          </a:solidFill>
+                          <a:latin typeface="Calibri" pitchFamily="34" charset="0"/>
+                          <a:ea typeface="Calibri" pitchFamily="34" charset="-122"/>
+                          <a:cs typeface="Calibri" pitchFamily="34" charset="-120"/>
+                        </a:rPr>
+                        <a:t>3-5 years EPC</a:t>
+                      </a:r>
+                      <a:endParaRPr lang="en-US" sz="850" dirty="0">
                         <a:latin typeface="Calibri" charset="0"/>
                         <a:ea typeface="Calibri" charset="0"/>
                         <a:cs typeface="Calibri" charset="0"/>
                       </a:endParaRPr>
                     </a:p>
                   </a:txBody>
-                  <a:tcPr marL="50800" marR="50800" marT="25400" marB="25400">
+                  <a:tcPr marL="91440" marR="91440" marT="45720" marB="45720" anchor="ctr">
                     <a:lnL w="0" cap="flat" cmpd="sng" algn="ctr">
                       <a:solidFill>
                         <a:srgbClr val="FFFFFF"/>
@@ -2882,9 +2722,9 @@
                       <a:headEnd type="none" w="med" len="med"/>
                       <a:tailEnd type="none" w="med" len="med"/>
                     </a:lnR>
-                    <a:lnT w="0" cap="flat" cmpd="sng" algn="ctr">
-                      <a:solidFill>
-                        <a:srgbClr val="FFFFFF"/>
+                    <a:lnT w="6350" cap="flat" cmpd="sng" algn="ctr">
+                      <a:solidFill>
+                        <a:srgbClr val="D0D0D0"/>
                       </a:solidFill>
                       <a:prstDash val="solid"/>
                       <a:round/>
@@ -2893,13 +2733,16 @@
                     </a:lnT>
                     <a:lnB w="6350" cap="flat" cmpd="sng" algn="ctr">
                       <a:solidFill>
-                        <a:srgbClr val="E8E8E8"/>
+                        <a:srgbClr val="D0D0D0"/>
                       </a:solidFill>
                       <a:prstDash val="solid"/>
                       <a:round/>
                       <a:headEnd type="none" w="med" len="med"/>
                       <a:tailEnd type="none" w="med" len="med"/>
                     </a:lnB>
+                    <a:solidFill>
+                      <a:srgbClr val="FFFFFF"/>
+                    </a:solidFill>
                   </a:tcPr>
                 </a:tc>
                 <a:tc>
@@ -2907,28 +2750,70 @@
                     <a:bodyPr/>
                     <a:lstStyle/>
                     <a:p>
-                      <a:pPr algn="ctr" indent="0" marL="0">
-                        <a:buNone/>
-                      </a:pPr>
-                      <a:r>
-                        <a:rPr lang="en-US" sz="800" dirty="0">
-                          <a:solidFill>
-                            <a:srgbClr val="404040"/>
-                          </a:solidFill>
-                          <a:latin typeface="Calibri" pitchFamily="34" charset="0"/>
-                          <a:ea typeface="Calibri" pitchFamily="34" charset="-122"/>
-                          <a:cs typeface="Calibri" pitchFamily="34" charset="-120"/>
-                        </a:rPr>
-                        <a:t>~500</a:t>
-                      </a:r>
-                      <a:endParaRPr lang="en-US" sz="800" dirty="0">
+                      <a:pPr indent="0" marL="0">
+                        <a:buNone/>
+                      </a:pPr>
+                      <a:r>
+                        <a:rPr lang="en-US" sz="850" dirty="0">
+                          <a:solidFill>
+                            <a:srgbClr val="333333"/>
+                          </a:solidFill>
+                          <a:latin typeface="Calibri" pitchFamily="34" charset="0"/>
+                          <a:ea typeface="Calibri" pitchFamily="34" charset="-122"/>
+                          <a:cs typeface="Calibri" pitchFamily="34" charset="-120"/>
+                        </a:rPr>
+                        <a:t>5-10+ years EPC duration,</a:t>
+                      </a:r>
+                      <a:endParaRPr lang="en-US" sz="850" dirty="0">
+                        <a:latin typeface="Calibri" charset="0"/>
+                        <a:ea typeface="Calibri" charset="0"/>
+                        <a:cs typeface="Calibri" charset="0"/>
+                      </a:endParaRPr>
+                    </a:p>
+                    <a:p>
+                      <a:pPr indent="0" marL="0">
+                        <a:buNone/>
+                      </a:pPr>
+                      <a:r>
+                        <a:rPr lang="en-US" sz="850" dirty="0">
+                          <a:solidFill>
+                            <a:srgbClr val="333333"/>
+                          </a:solidFill>
+                          <a:latin typeface="Calibri" pitchFamily="34" charset="0"/>
+                          <a:ea typeface="Calibri" pitchFamily="34" charset="-122"/>
+                          <a:cs typeface="Calibri" pitchFamily="34" charset="-120"/>
+                        </a:rPr>
+                        <a:t>contingent upon development</a:t>
+                      </a:r>
+                      <a:endParaRPr lang="en-US" sz="850" dirty="0">
+                        <a:latin typeface="Calibri" charset="0"/>
+                        <a:ea typeface="Calibri" charset="0"/>
+                        <a:cs typeface="Calibri" charset="0"/>
+                      </a:endParaRPr>
+                    </a:p>
+                    <a:p>
+                      <a:pPr indent="0" marL="0">
+                        <a:buNone/>
+                      </a:pPr>
+                      <a:r>
+                        <a:rPr lang="en-US" sz="850" dirty="0">
+                          <a:solidFill>
+                            <a:srgbClr val="333333"/>
+                          </a:solidFill>
+                          <a:latin typeface="Calibri" pitchFamily="34" charset="0"/>
+                          <a:ea typeface="Calibri" pitchFamily="34" charset="-122"/>
+                          <a:cs typeface="Calibri" pitchFamily="34" charset="-120"/>
+                        </a:rPr>
+                        <a:t>of CO2 storage site</a:t>
+                      </a:r>
+                      <a:endParaRPr lang="en-US" sz="850" dirty="0">
                         <a:latin typeface="Calibri" charset="0"/>
                         <a:ea typeface="Calibri" charset="0"/>
                         <a:cs typeface="Calibri" charset="0"/>
                       </a:endParaRPr>
                     </a:p>
                   </a:txBody>
-                  <a:tcPr marL="50800" marR="50800" marT="25400" marB="25400">
+                  <a:tcPr marL="91440" marR="91440" marT="45720" marB="45720" anchor="ctr">
                     <a:lnL w="0" cap="flat" cmpd="sng" algn="ctr">
                       <a:solidFill>
                         <a:srgbClr val="FFFFFF"/>
@@ -2947,9 +2832,9 @@
                       <a:headEnd type="none" w="med" len="med"/>
                       <a:tailEnd type="none" w="med" len="med"/>
                     </a:lnR>
-                    <a:lnT w="0" cap="flat" cmpd="sng" algn="ctr">
-                      <a:solidFill>
-                        <a:srgbClr val="FFFFFF"/>
+                    <a:lnT w="6350" cap="flat" cmpd="sng" algn="ctr">
+                      <a:solidFill>
+                        <a:srgbClr val="D0D0D0"/>
                       </a:solidFill>
                       <a:prstDash val="solid"/>
                       <a:round/>
@@ -2958,13 +2843,16 @@
                     </a:lnT>
                     <a:lnB w="6350" cap="flat" cmpd="sng" algn="ctr">
                       <a:solidFill>
-                        <a:srgbClr val="E8E8E8"/>
+                        <a:srgbClr val="D0D0D0"/>
                       </a:solidFill>
                       <a:prstDash val="solid"/>
                       <a:round/>
                       <a:headEnd type="none" w="med" len="med"/>
                       <a:tailEnd type="none" w="med" len="med"/>
                     </a:lnB>
+                    <a:solidFill>
+                      <a:srgbClr val="FFFFFF"/>
+                    </a:solidFill>
                   </a:tcPr>
                 </a:tc>
                 <a:tc>
@@ -2972,28 +2860,28 @@
                     <a:bodyPr/>
                     <a:lstStyle/>
                     <a:p>
-                      <a:pPr algn="ctr" indent="0" marL="0">
-                        <a:buNone/>
-                      </a:pPr>
-                      <a:r>
-                        <a:rPr lang="en-US" sz="800" dirty="0">
-                          <a:solidFill>
-                            <a:srgbClr val="404040"/>
-                          </a:solidFill>
-                          <a:latin typeface="Calibri" pitchFamily="34" charset="0"/>
-                          <a:ea typeface="Calibri" pitchFamily="34" charset="-122"/>
-                          <a:cs typeface="Calibri" pitchFamily="34" charset="-120"/>
-                        </a:rPr>
-                        <a:t>~1,200</a:t>
-                      </a:r>
-                      <a:endParaRPr lang="en-US" sz="800" dirty="0">
+                      <a:pPr indent="0" marL="0">
+                        <a:buNone/>
+                      </a:pPr>
+                      <a:r>
+                        <a:rPr lang="en-US" sz="850" dirty="0">
+                          <a:solidFill>
+                            <a:srgbClr val="333333"/>
+                          </a:solidFill>
+                          <a:latin typeface="Calibri" pitchFamily="34" charset="0"/>
+                          <a:ea typeface="Calibri" pitchFamily="34" charset="-122"/>
+                          <a:cs typeface="Calibri" pitchFamily="34" charset="-120"/>
+                        </a:rPr>
+                        <a:t>1-3 years EPC duration</a:t>
+                      </a:r>
+                      <a:endParaRPr lang="en-US" sz="850" dirty="0">
                         <a:latin typeface="Calibri" charset="0"/>
                         <a:ea typeface="Calibri" charset="0"/>
                         <a:cs typeface="Calibri" charset="0"/>
                       </a:endParaRPr>
                     </a:p>
                   </a:txBody>
-                  <a:tcPr marL="50800" marR="50800" marT="25400" marB="25400">
+                  <a:tcPr marL="91440" marR="91440" marT="45720" marB="45720" anchor="ctr">
                     <a:lnL w="0" cap="flat" cmpd="sng" algn="ctr">
                       <a:solidFill>
                         <a:srgbClr val="FFFFFF"/>
@@ -3012,9 +2900,9 @@
                       <a:headEnd type="none" w="med" len="med"/>
                       <a:tailEnd type="none" w="med" len="med"/>
                     </a:lnR>
-                    <a:lnT w="0" cap="flat" cmpd="sng" algn="ctr">
-                      <a:solidFill>
-                        <a:srgbClr val="FFFFFF"/>
+                    <a:lnT w="6350" cap="flat" cmpd="sng" algn="ctr">
+                      <a:solidFill>
+                        <a:srgbClr val="D0D0D0"/>
                       </a:solidFill>
                       <a:prstDash val="solid"/>
                       <a:round/>
@@ -3023,44 +2911,68 @@
                     </a:lnT>
                     <a:lnB w="6350" cap="flat" cmpd="sng" algn="ctr">
                       <a:solidFill>
-                        <a:srgbClr val="E8E8E8"/>
+                        <a:srgbClr val="D0D0D0"/>
                       </a:solidFill>
                       <a:prstDash val="solid"/>
                       <a:round/>
                       <a:headEnd type="none" w="med" len="med"/>
                       <a:tailEnd type="none" w="med" len="med"/>
                     </a:lnB>
+                    <a:solidFill>
+                      <a:srgbClr val="FFFFFF"/>
+                    </a:solidFill>
                   </a:tcPr>
                 </a:tc>
               </a:tr>
-              <a:tr h="292608">
+              <a:tr h="274320">
                 <a:tc>
                   <a:txBody>
                     <a:bodyPr/>
                     <a:lstStyle/>
                     <a:p>
-                      <a:pPr algn="l" indent="0" marL="0">
-                        <a:buNone/>
-                      </a:pPr>
-                      <a:r>
-                        <a:rPr lang="en-US" sz="900" b="1" dirty="0">
-                          <a:solidFill>
-                            <a:srgbClr val="222222"/>
-                          </a:solidFill>
-                          <a:latin typeface="Calibri" pitchFamily="34" charset="0"/>
-                          <a:ea typeface="Calibri" pitchFamily="34" charset="-122"/>
-                          <a:cs typeface="Calibri" pitchFamily="34" charset="-120"/>
-                        </a:rPr>
-                        <a:t>Infrastructure investment (€bn)</a:t>
-                      </a:r>
-                      <a:endParaRPr lang="en-US" sz="900" dirty="0">
+                      <a:pPr indent="0" marL="0">
+                        <a:buNone/>
+                      </a:pPr>
+                      <a:r>
+                        <a:rPr lang="en-US" sz="850" b="1" dirty="0">
+                          <a:solidFill>
+                            <a:srgbClr val="000000"/>
+                          </a:solidFill>
+                          <a:latin typeface="Calibri" pitchFamily="34" charset="0"/>
+                          <a:ea typeface="Calibri" pitchFamily="34" charset="-122"/>
+                          <a:cs typeface="Calibri" pitchFamily="34" charset="-120"/>
+                        </a:rPr>
+                        <a:t>Direct link to</a:t>
+                      </a:r>
+                      <a:endParaRPr lang="en-US" sz="850" dirty="0">
+                        <a:latin typeface="Calibri" charset="0"/>
+                        <a:ea typeface="Calibri" charset="0"/>
+                        <a:cs typeface="Calibri" charset="0"/>
+                      </a:endParaRPr>
+                    </a:p>
+                    <a:p>
+                      <a:pPr indent="0" marL="0">
+                        <a:buNone/>
+                      </a:pPr>
+                      <a:r>
+                        <a:rPr lang="en-US" sz="850" b="1" dirty="0">
+                          <a:solidFill>
+                            <a:srgbClr val="000000"/>
+                          </a:solidFill>
+                          <a:latin typeface="Calibri" pitchFamily="34" charset="0"/>
+                          <a:ea typeface="Calibri" pitchFamily="34" charset="-122"/>
+                          <a:cs typeface="Calibri" pitchFamily="34" charset="-120"/>
+                        </a:rPr>
+                        <a:t>power sector</a:t>
+                      </a:r>
+                      <a:endParaRPr lang="en-US" sz="850" dirty="0">
                         <a:latin typeface="Calibri" charset="0"/>
                         <a:ea typeface="Calibri" charset="0"/>
                         <a:cs typeface="Calibri" charset="0"/>
                       </a:endParaRPr>
                     </a:p>
                   </a:txBody>
-                  <a:tcPr marL="50800" marR="50800" marT="25400" marB="25400">
+                  <a:tcPr marL="91440" marR="91440" marT="45720" marB="45720" anchor="ctr">
                     <a:lnL w="0" cap="flat" cmpd="sng" algn="ctr">
                       <a:solidFill>
                         <a:srgbClr val="FFFFFF"/>
@@ -3079,24 +2991,27 @@
                       <a:headEnd type="none" w="med" len="med"/>
                       <a:tailEnd type="none" w="med" len="med"/>
                     </a:lnR>
-                    <a:lnT w="0" cap="flat" cmpd="sng" algn="ctr">
-                      <a:solidFill>
-                        <a:srgbClr val="FFFFFF"/>
+                    <a:lnT w="6350" cap="flat" cmpd="sng" algn="ctr">
+                      <a:solidFill>
+                        <a:srgbClr val="D0D0D0"/>
                       </a:solidFill>
                       <a:prstDash val="solid"/>
                       <a:round/>
                       <a:headEnd type="none" w="med" len="med"/>
                       <a:tailEnd type="none" w="med" len="med"/>
                     </a:lnT>
-                    <a:lnB w="12700" cap="flat" cmpd="sng" algn="ctr">
-                      <a:solidFill>
-                        <a:srgbClr val="0C2340"/>
+                    <a:lnB w="6350" cap="flat" cmpd="sng" algn="ctr">
+                      <a:solidFill>
+                        <a:srgbClr val="D0D0D0"/>
                       </a:solidFill>
                       <a:prstDash val="solid"/>
                       <a:round/>
                       <a:headEnd type="none" w="med" len="med"/>
                       <a:tailEnd type="none" w="med" len="med"/>
                     </a:lnB>
+                    <a:solidFill>
+                      <a:srgbClr val="FFFFFF"/>
+                    </a:solidFill>
                   </a:tcPr>
                 </a:tc>
                 <a:tc>
@@ -3104,28 +3019,28 @@
                     <a:bodyPr/>
                     <a:lstStyle/>
                     <a:p>
-                      <a:pPr algn="ctr" indent="0" marL="0">
-                        <a:buNone/>
-                      </a:pPr>
-                      <a:r>
-                        <a:rPr lang="en-US" sz="800" dirty="0">
-                          <a:solidFill>
-                            <a:srgbClr val="404040"/>
-                          </a:solidFill>
-                          <a:latin typeface="Calibri" pitchFamily="34" charset="0"/>
-                          <a:ea typeface="Calibri" pitchFamily="34" charset="-122"/>
-                          <a:cs typeface="Calibri" pitchFamily="34" charset="-120"/>
-                        </a:rPr>
-                        <a:t>0.5</a:t>
-                      </a:r>
-                      <a:endParaRPr lang="en-US" sz="800" dirty="0">
+                      <a:pPr indent="0" marL="0">
+                        <a:buNone/>
+                      </a:pPr>
+                      <a:r>
+                        <a:rPr lang="en-US" sz="850" dirty="0">
+                          <a:solidFill>
+                            <a:srgbClr val="333333"/>
+                          </a:solidFill>
+                          <a:latin typeface="Calibri" pitchFamily="34" charset="0"/>
+                          <a:ea typeface="Calibri" pitchFamily="34" charset="-122"/>
+                          <a:cs typeface="Calibri" pitchFamily="34" charset="-120"/>
+                        </a:rPr>
+                        <a:t>X</a:t>
+                      </a:r>
+                      <a:endParaRPr lang="en-US" sz="850" dirty="0">
                         <a:latin typeface="Calibri" charset="0"/>
                         <a:ea typeface="Calibri" charset="0"/>
                         <a:cs typeface="Calibri" charset="0"/>
                       </a:endParaRPr>
                     </a:p>
                   </a:txBody>
-                  <a:tcPr marL="50800" marR="50800" marT="25400" marB="25400">
+                  <a:tcPr marL="91440" marR="91440" marT="45720" marB="45720" anchor="ctr">
                     <a:lnL w="0" cap="flat" cmpd="sng" algn="ctr">
                       <a:solidFill>
                         <a:srgbClr val="FFFFFF"/>
@@ -3144,24 +3059,27 @@
                       <a:headEnd type="none" w="med" len="med"/>
                       <a:tailEnd type="none" w="med" len="med"/>
                     </a:lnR>
-                    <a:lnT w="0" cap="flat" cmpd="sng" algn="ctr">
-                      <a:solidFill>
-                        <a:srgbClr val="FFFFFF"/>
+                    <a:lnT w="6350" cap="flat" cmpd="sng" algn="ctr">
+                      <a:solidFill>
+                        <a:srgbClr val="D0D0D0"/>
                       </a:solidFill>
                       <a:prstDash val="solid"/>
                       <a:round/>
                       <a:headEnd type="none" w="med" len="med"/>
                       <a:tailEnd type="none" w="med" len="med"/>
                     </a:lnT>
-                    <a:lnB w="12700" cap="flat" cmpd="sng" algn="ctr">
-                      <a:solidFill>
-                        <a:srgbClr val="0C2340"/>
+                    <a:lnB w="6350" cap="flat" cmpd="sng" algn="ctr">
+                      <a:solidFill>
+                        <a:srgbClr val="D0D0D0"/>
                       </a:solidFill>
                       <a:prstDash val="solid"/>
                       <a:round/>
                       <a:headEnd type="none" w="med" len="med"/>
                       <a:tailEnd type="none" w="med" len="med"/>
                     </a:lnB>
+                    <a:solidFill>
+                      <a:srgbClr val="FFFFFF"/>
+                    </a:solidFill>
                   </a:tcPr>
                 </a:tc>
                 <a:tc>
@@ -3169,28 +3087,28 @@
                     <a:bodyPr/>
                     <a:lstStyle/>
                     <a:p>
-                      <a:pPr algn="ctr" indent="0" marL="0">
-                        <a:buNone/>
-                      </a:pPr>
-                      <a:r>
-                        <a:rPr lang="en-US" sz="800" dirty="0">
-                          <a:solidFill>
-                            <a:srgbClr val="404040"/>
-                          </a:solidFill>
-                          <a:latin typeface="Calibri" pitchFamily="34" charset="0"/>
-                          <a:ea typeface="Calibri" pitchFamily="34" charset="-122"/>
-                          <a:cs typeface="Calibri" pitchFamily="34" charset="-120"/>
-                        </a:rPr>
-                        <a:t>3.5</a:t>
-                      </a:r>
-                      <a:endParaRPr lang="en-US" sz="800" dirty="0">
+                      <a:pPr indent="0" marL="0">
+                        <a:buNone/>
+                      </a:pPr>
+                      <a:r>
+                        <a:rPr lang="en-US" sz="850" dirty="0">
+                          <a:solidFill>
+                            <a:srgbClr val="333333"/>
+                          </a:solidFill>
+                          <a:latin typeface="Calibri" pitchFamily="34" charset="0"/>
+                          <a:ea typeface="Calibri" pitchFamily="34" charset="-122"/>
+                          <a:cs typeface="Calibri" pitchFamily="34" charset="-120"/>
+                        </a:rPr>
+                        <a:t>X</a:t>
+                      </a:r>
+                      <a:endParaRPr lang="en-US" sz="850" dirty="0">
                         <a:latin typeface="Calibri" charset="0"/>
                         <a:ea typeface="Calibri" charset="0"/>
                         <a:cs typeface="Calibri" charset="0"/>
                       </a:endParaRPr>
                     </a:p>
                   </a:txBody>
-                  <a:tcPr marL="50800" marR="50800" marT="25400" marB="25400">
+                  <a:tcPr marL="91440" marR="91440" marT="45720" marB="45720" anchor="ctr">
                     <a:lnL w="0" cap="flat" cmpd="sng" algn="ctr">
                       <a:solidFill>
                         <a:srgbClr val="FFFFFF"/>
@@ -3209,24 +3127,27 @@
                       <a:headEnd type="none" w="med" len="med"/>
                       <a:tailEnd type="none" w="med" len="med"/>
                     </a:lnR>
-                    <a:lnT w="0" cap="flat" cmpd="sng" algn="ctr">
-                      <a:solidFill>
-                        <a:srgbClr val="FFFFFF"/>
+                    <a:lnT w="6350" cap="flat" cmpd="sng" algn="ctr">
+                      <a:solidFill>
+                        <a:srgbClr val="D0D0D0"/>
                       </a:solidFill>
                       <a:prstDash val="solid"/>
                       <a:round/>
                       <a:headEnd type="none" w="med" len="med"/>
                       <a:tailEnd type="none" w="med" len="med"/>
                     </a:lnT>
-                    <a:lnB w="12700" cap="flat" cmpd="sng" algn="ctr">
-                      <a:solidFill>
-                        <a:srgbClr val="0C2340"/>
+                    <a:lnB w="6350" cap="flat" cmpd="sng" algn="ctr">
+                      <a:solidFill>
+                        <a:srgbClr val="D0D0D0"/>
                       </a:solidFill>
                       <a:prstDash val="solid"/>
                       <a:round/>
                       <a:headEnd type="none" w="med" len="med"/>
                       <a:tailEnd type="none" w="med" len="med"/>
                     </a:lnB>
+                    <a:solidFill>
+                      <a:srgbClr val="FFFFFF"/>
+                    </a:solidFill>
                   </a:tcPr>
                 </a:tc>
                 <a:tc>
@@ -3234,28 +3155,28 @@
                     <a:bodyPr/>
                     <a:lstStyle/>
                     <a:p>
-                      <a:pPr algn="ctr" indent="0" marL="0">
-                        <a:buNone/>
-                      </a:pPr>
-                      <a:r>
-                        <a:rPr lang="en-US" sz="800" dirty="0">
-                          <a:solidFill>
-                            <a:srgbClr val="404040"/>
-                          </a:solidFill>
-                          <a:latin typeface="Calibri" pitchFamily="34" charset="0"/>
-                          <a:ea typeface="Calibri" pitchFamily="34" charset="-122"/>
-                          <a:cs typeface="Calibri" pitchFamily="34" charset="-120"/>
-                        </a:rPr>
-                        <a:t>9</a:t>
-                      </a:r>
-                      <a:endParaRPr lang="en-US" sz="800" dirty="0">
+                      <a:pPr indent="0" marL="0">
+                        <a:buNone/>
+                      </a:pPr>
+                      <a:r>
+                        <a:rPr lang="en-US" sz="850" dirty="0">
+                          <a:solidFill>
+                            <a:srgbClr val="333333"/>
+                          </a:solidFill>
+                          <a:latin typeface="Calibri" pitchFamily="34" charset="0"/>
+                          <a:ea typeface="Calibri" pitchFamily="34" charset="-122"/>
+                          <a:cs typeface="Calibri" pitchFamily="34" charset="-120"/>
+                        </a:rPr>
+                        <a:t>✓</a:t>
+                      </a:r>
+                      <a:endParaRPr lang="en-US" sz="850" dirty="0">
                         <a:latin typeface="Calibri" charset="0"/>
                         <a:ea typeface="Calibri" charset="0"/>
                         <a:cs typeface="Calibri" charset="0"/>
                       </a:endParaRPr>
                     </a:p>
                   </a:txBody>
-                  <a:tcPr marL="50800" marR="50800" marT="25400" marB="25400">
+                  <a:tcPr marL="91440" marR="91440" marT="45720" marB="45720" anchor="ctr">
                     <a:lnL w="0" cap="flat" cmpd="sng" algn="ctr">
                       <a:solidFill>
                         <a:srgbClr val="FFFFFF"/>
@@ -3274,154 +3195,27 @@
                       <a:headEnd type="none" w="med" len="med"/>
                       <a:tailEnd type="none" w="med" len="med"/>
                     </a:lnR>
-                    <a:lnT w="0" cap="flat" cmpd="sng" algn="ctr">
-                      <a:solidFill>
-                        <a:srgbClr val="FFFFFF"/>
+                    <a:lnT w="6350" cap="flat" cmpd="sng" algn="ctr">
+                      <a:solidFill>
+                        <a:srgbClr val="D0D0D0"/>
                       </a:solidFill>
                       <a:prstDash val="solid"/>
                       <a:round/>
                       <a:headEnd type="none" w="med" len="med"/>
                       <a:tailEnd type="none" w="med" len="med"/>
                     </a:lnT>
-                    <a:lnB w="12700" cap="flat" cmpd="sng" algn="ctr">
-                      <a:solidFill>
-                        <a:srgbClr val="0C2340"/>
+                    <a:lnB w="6350" cap="flat" cmpd="sng" algn="ctr">
+                      <a:solidFill>
+                        <a:srgbClr val="D0D0D0"/>
                       </a:solidFill>
                       <a:prstDash val="solid"/>
                       <a:round/>
                       <a:headEnd type="none" w="med" len="med"/>
                       <a:tailEnd type="none" w="med" len="med"/>
                     </a:lnB>
-                  </a:tcPr>
-                </a:tc>
-                <a:tc>
-                  <a:txBody>
-                    <a:bodyPr/>
-                    <a:lstStyle/>
-                    <a:p>
-                      <a:pPr algn="ctr" indent="0" marL="0">
-                        <a:buNone/>
-                      </a:pPr>
-                      <a:r>
-                        <a:rPr lang="en-US" sz="800" dirty="0">
-                          <a:solidFill>
-                            <a:srgbClr val="404040"/>
-                          </a:solidFill>
-                          <a:latin typeface="Calibri" pitchFamily="34" charset="0"/>
-                          <a:ea typeface="Calibri" pitchFamily="34" charset="-122"/>
-                          <a:cs typeface="Calibri" pitchFamily="34" charset="-120"/>
-                        </a:rPr>
-                        <a:t>15</a:t>
-                      </a:r>
-                      <a:endParaRPr lang="en-US" sz="800" dirty="0">
-                        <a:latin typeface="Calibri" charset="0"/>
-                        <a:ea typeface="Calibri" charset="0"/>
-                        <a:cs typeface="Calibri" charset="0"/>
-                      </a:endParaRPr>
-                    </a:p>
-                  </a:txBody>
-                  <a:tcPr marL="50800" marR="50800" marT="25400" marB="25400">
-                    <a:lnL w="0" cap="flat" cmpd="sng" algn="ctr">
-                      <a:solidFill>
-                        <a:srgbClr val="FFFFFF"/>
-                      </a:solidFill>
-                      <a:prstDash val="solid"/>
-                      <a:round/>
-                      <a:headEnd type="none" w="med" len="med"/>
-                      <a:tailEnd type="none" w="med" len="med"/>
-                    </a:lnL>
-                    <a:lnR w="0" cap="flat" cmpd="sng" algn="ctr">
-                      <a:solidFill>
-                        <a:srgbClr val="FFFFFF"/>
-                      </a:solidFill>
-                      <a:prstDash val="solid"/>
-                      <a:round/>
-                      <a:headEnd type="none" w="med" len="med"/>
-                      <a:tailEnd type="none" w="med" len="med"/>
-                    </a:lnR>
-                    <a:lnT w="0" cap="flat" cmpd="sng" algn="ctr">
-                      <a:solidFill>
-                        <a:srgbClr val="FFFFFF"/>
-                      </a:solidFill>
-                      <a:prstDash val="solid"/>
-                      <a:round/>
-                      <a:headEnd type="none" w="med" len="med"/>
-                      <a:tailEnd type="none" w="med" len="med"/>
-                    </a:lnT>
-                    <a:lnB w="12700" cap="flat" cmpd="sng" algn="ctr">
-                      <a:solidFill>
-                        <a:srgbClr val="0C2340"/>
-                      </a:solidFill>
-                      <a:prstDash val="solid"/>
-                      <a:round/>
-                      <a:headEnd type="none" w="med" len="med"/>
-                      <a:tailEnd type="none" w="med" len="med"/>
-                    </a:lnB>
-                  </a:tcPr>
-                </a:tc>
-                <a:tc>
-                  <a:txBody>
-                    <a:bodyPr/>
-                    <a:lstStyle/>
-                    <a:p>
-                      <a:pPr algn="ctr" indent="0" marL="0">
-                        <a:buNone/>
-                      </a:pPr>
-                      <a:r>
-                        <a:rPr lang="en-US" sz="800" dirty="0">
-                          <a:solidFill>
-                            <a:srgbClr val="404040"/>
-                          </a:solidFill>
-                          <a:latin typeface="Calibri" pitchFamily="34" charset="0"/>
-                          <a:ea typeface="Calibri" pitchFamily="34" charset="-122"/>
-                          <a:cs typeface="Calibri" pitchFamily="34" charset="-120"/>
-                        </a:rPr>
-                        <a:t>25+</a:t>
-                      </a:r>
-                      <a:endParaRPr lang="en-US" sz="800" dirty="0">
-                        <a:latin typeface="Calibri" charset="0"/>
-                        <a:ea typeface="Calibri" charset="0"/>
-                        <a:cs typeface="Calibri" charset="0"/>
-                      </a:endParaRPr>
-                    </a:p>
-                  </a:txBody>
-                  <a:tcPr marL="50800" marR="50800" marT="25400" marB="25400">
-                    <a:lnL w="0" cap="flat" cmpd="sng" algn="ctr">
-                      <a:solidFill>
-                        <a:srgbClr val="FFFFFF"/>
-                      </a:solidFill>
-                      <a:prstDash val="solid"/>
-                      <a:round/>
-                      <a:headEnd type="none" w="med" len="med"/>
-                      <a:tailEnd type="none" w="med" len="med"/>
-                    </a:lnL>
-                    <a:lnR w="0" cap="flat" cmpd="sng" algn="ctr">
-                      <a:solidFill>
-                        <a:srgbClr val="FFFFFF"/>
-                      </a:solidFill>
-                      <a:prstDash val="solid"/>
-                      <a:round/>
-                      <a:headEnd type="none" w="med" len="med"/>
-                      <a:tailEnd type="none" w="med" len="med"/>
-                    </a:lnR>
-                    <a:lnT w="0" cap="flat" cmpd="sng" algn="ctr">
-                      <a:solidFill>
-                        <a:srgbClr val="FFFFFF"/>
-                      </a:solidFill>
-                      <a:prstDash val="solid"/>
-                      <a:round/>
-                      <a:headEnd type="none" w="med" len="med"/>
-                      <a:tailEnd type="none" w="med" len="med"/>
-                    </a:lnT>
-                    <a:lnB w="12700" cap="flat" cmpd="sng" algn="ctr">
-                      <a:solidFill>
-                        <a:srgbClr val="0C2340"/>
-                      </a:solidFill>
-                      <a:prstDash val="solid"/>
-                      <a:round/>
-                      <a:headEnd type="none" w="med" len="med"/>
-                      <a:tailEnd type="none" w="med" len="med"/>
-                    </a:lnB>
+                    <a:solidFill>
+                      <a:srgbClr val="FFFFFF"/>
+                    </a:solidFill>
                   </a:tcPr>
                 </a:tc>
               </a:tr>
@@ -3431,14 +3225,14 @@
       </p:graphicFrame>
       <p:sp>
         <p:nvSpPr>
-          <p:cNvPr id="31" name="Text 28"/>
+          <p:cNvPr id="8" name="Text 5"/>
           <p:cNvSpPr/>
           <p:nvPr/>
         </p:nvSpPr>
         <p:spPr>
           <a:xfrm>
-            <a:off x="457200" y="4572000"/>
-            <a:ext cx="11274552" cy="182880"/>
+            <a:off x="457200" y="3840480"/>
+            <a:ext cx="7772400" cy="411480"/>
           </a:xfrm>
           <a:prstGeom prst="rect">
             <a:avLst/>
@@ -3447,37 +3241,100 @@
           <a:ln/>
         </p:spPr>
         <p:txBody>
-          <a:bodyPr wrap="square" lIns="0" tIns="0" rIns="0" bIns="0" rtlCol="0" anchor="t"/>
+          <a:bodyPr wrap="square" lIns="0" tIns="0" rIns="0" bIns="0" rtlCol="0" anchor="ctr"/>
           <a:lstStyle/>
           <a:p>
             <a:pPr indent="0" marL="0">
+              <a:lnSpc>
+                <a:spcPct val="115000"/>
+              </a:lnSpc>
               <a:buNone/>
             </a:pPr>
             <a:r>
-              <a:rPr lang="en-US" sz="650" i="1" dirty="0">
+              <a:rPr lang="en-US" sz="600" dirty="0">
                 <a:solidFill>
-                  <a:srgbClr val="999999"/>
+                  <a:srgbClr val="666666"/>
                 </a:solidFill>
                 <a:latin typeface="Calibri" pitchFamily="34" charset="0"/>
                 <a:ea typeface="Calibri" pitchFamily="34" charset="-122"/>
                 <a:cs typeface="Calibri" pitchFamily="34" charset="-120"/>
               </a:rPr>
-              <a:t>Note: Capacity targets reflect government ambitions as of 2024; actual deployment subject to policy and market conditions.</a:t>
+              <a:t>1.  Process: Sulfur Removal, Synthesis Gas Production via Steam-Methane Reforming (SMR) or Auto-Thermal Reforming (ATR), CO Shift Reaction,</a:t>
             </a:r>
-            <a:endParaRPr lang="en-US" sz="650" dirty="0"/>
+            <a:endParaRPr lang="en-US" sz="600" dirty="0"/>
+          </a:p>
+          <a:p>
+            <a:pPr indent="0" marL="0">
+              <a:lnSpc>
+                <a:spcPct val="115000"/>
+              </a:lnSpc>
+              <a:buNone/>
+            </a:pPr>
+            <a:r>
+              <a:rPr lang="en-US" sz="600" dirty="0">
+                <a:solidFill>
+                  <a:srgbClr val="666666"/>
+                </a:solidFill>
+                <a:latin typeface="Calibri" pitchFamily="34" charset="0"/>
+                <a:ea typeface="Calibri" pitchFamily="34" charset="-122"/>
+                <a:cs typeface="Calibri" pitchFamily="34" charset="-120"/>
+              </a:rPr>
+              <a:t>     Purification. The latter is expected to offer higher efficiencies in combination with CCS. Grey hydrogen can also be produced from coal gasification.</a:t>
+            </a:r>
+            <a:endParaRPr lang="en-US" sz="600" dirty="0"/>
+          </a:p>
+          <a:p>
+            <a:pPr indent="0" marL="0">
+              <a:lnSpc>
+                <a:spcPct val="115000"/>
+              </a:lnSpc>
+              <a:buNone/>
+            </a:pPr>
+            <a:r>
+              <a:rPr lang="en-US" sz="600" dirty="0">
+                <a:solidFill>
+                  <a:srgbClr val="666666"/>
+                </a:solidFill>
+                <a:latin typeface="Calibri" pitchFamily="34" charset="0"/>
+                <a:ea typeface="Calibri" pitchFamily="34" charset="-122"/>
+                <a:cs typeface="Calibri" pitchFamily="34" charset="-120"/>
+              </a:rPr>
+              <a:t>2.  In Australia, producing hydrogen from electrolyzers that run on grid electricity would lead to an emission intensity of ~40 kgCO2/kgH2.</a:t>
+            </a:r>
+            <a:endParaRPr lang="en-US" sz="600" dirty="0"/>
+          </a:p>
+          <a:p>
+            <a:pPr indent="0" marL="0">
+              <a:lnSpc>
+                <a:spcPct val="115000"/>
+              </a:lnSpc>
+              <a:buNone/>
+            </a:pPr>
+            <a:r>
+              <a:rPr lang="en-US" sz="600" dirty="0">
+                <a:solidFill>
+                  <a:srgbClr val="666666"/>
+                </a:solidFill>
+                <a:latin typeface="Calibri" pitchFamily="34" charset="0"/>
+                <a:ea typeface="Calibri" pitchFamily="34" charset="-122"/>
+                <a:cs typeface="Calibri" pitchFamily="34" charset="-120"/>
+              </a:rPr>
+              <a:t>3.  Especially PEM electrolyzers can be largely pre-assembled, containerized, and stacked.</a:t>
+            </a:r>
+            <a:endParaRPr lang="en-US" sz="600" dirty="0"/>
           </a:p>
         </p:txBody>
       </p:sp>
       <p:sp>
         <p:nvSpPr>
-          <p:cNvPr id="32" name="Shape 29"/>
+          <p:cNvPr id="9" name="Shape 6"/>
           <p:cNvSpPr/>
           <p:nvPr/>
         </p:nvSpPr>
         <p:spPr>
           <a:xfrm>
-            <a:off x="457200" y="5852160"/>
-            <a:ext cx="11274552" cy="0"/>
+            <a:off x="457200" y="4663440"/>
+            <a:ext cx="8229600" cy="0"/>
           </a:xfrm>
           <a:prstGeom prst="line">
             <a:avLst/>
@@ -3493,14 +3350,14 @@
       </p:sp>
       <p:sp>
         <p:nvSpPr>
-          <p:cNvPr id="33" name="Text 30"/>
+          <p:cNvPr id="10" name="Text 7"/>
           <p:cNvSpPr/>
           <p:nvPr/>
         </p:nvSpPr>
         <p:spPr>
           <a:xfrm>
-            <a:off x="457200" y="5897880"/>
-            <a:ext cx="7315200" cy="182880"/>
+            <a:off x="6400800" y="4709160"/>
+            <a:ext cx="2286000" cy="182880"/>
           </a:xfrm>
           <a:prstGeom prst="rect">
             <a:avLst/>
@@ -3509,75 +3366,22 @@
           <a:ln/>
         </p:spPr>
         <p:txBody>
-          <a:bodyPr wrap="square" lIns="0" tIns="0" rIns="0" bIns="0" rtlCol="0" anchor="t"/>
-          <a:lstStyle/>
-          <a:p>
-            <a:pPr indent="0" marL="0">
-              <a:buNone/>
-            </a:pPr>
-            <a:r>
-              <a:rPr lang="en-US" sz="700" dirty="0">
-                <a:solidFill>
-                  <a:srgbClr val="999999"/>
-                </a:solidFill>
-                <a:latin typeface="Calibri" pitchFamily="34" charset="0"/>
-                <a:ea typeface="Calibri" pitchFamily="34" charset="-122"/>
-                <a:cs typeface="Calibri" pitchFamily="34" charset="-120"/>
-              </a:rPr>
-              <a:t>Source: Government of the Netherlands, National Hydrogen Strategy; European Commission, REPowerEU Plan (2022).</a:t>
-            </a:r>
-            <a:endParaRPr lang="en-US" sz="700" dirty="0"/>
-          </a:p>
-        </p:txBody>
-      </p:sp>
-      <p:sp>
-        <p:nvSpPr>
-          <p:cNvPr id="34" name="Text 31"/>
-          <p:cNvSpPr/>
-          <p:nvPr/>
-        </p:nvSpPr>
-        <p:spPr>
-          <a:xfrm>
-            <a:off x="7772400" y="5897880"/>
-            <a:ext cx="3959352" cy="182880"/>
-          </a:xfrm>
-          <a:prstGeom prst="rect">
-            <a:avLst/>
-          </a:prstGeom>
-          <a:noFill/>
-          <a:ln/>
-        </p:spPr>
-        <p:txBody>
-          <a:bodyPr wrap="square" lIns="0" tIns="0" rIns="0" bIns="0" rtlCol="0" anchor="t"/>
+          <a:bodyPr wrap="square" lIns="0" tIns="0" rIns="0" bIns="0" rtlCol="0" anchor="ctr"/>
           <a:lstStyle/>
           <a:p>
             <a:pPr algn="r" indent="0" marL="0">
               <a:buNone/>
             </a:pPr>
             <a:r>
-              <a:rPr lang="en-US" sz="800" b="1" dirty="0">
+              <a:rPr lang="en-US" sz="800" dirty="0">
                 <a:solidFill>
-                  <a:srgbClr val="000000"/>
+                  <a:srgbClr val="666666"/>
                 </a:solidFill>
                 <a:latin typeface="Calibri" pitchFamily="34" charset="0"/>
                 <a:ea typeface="Calibri" pitchFamily="34" charset="-122"/>
                 <a:cs typeface="Calibri" pitchFamily="34" charset="-120"/>
               </a:rPr>
-              <a:t>McKinsey &amp; Company</a:t>
-            </a:r>
-            <a:pPr algn="r" indent="0" marL="0">
-              <a:buNone/>
-            </a:pPr>
-            <a:r>
-              <a:rPr lang="en-US" sz="800" dirty="0">
-                <a:solidFill>
-                  <a:srgbClr val="000000"/>
-                </a:solidFill>
-                <a:latin typeface="Calibri" pitchFamily="34" charset="0"/>
-                <a:ea typeface="Calibri" pitchFamily="34" charset="-122"/>
-                <a:cs typeface="Calibri" pitchFamily="34" charset="-120"/>
-              </a:rPr>
-              <a:t>  1</a:t>
+              <a:t>McKinsey &amp; Company    4</a:t>
             </a:r>
             <a:endParaRPr lang="en-US" sz="800" dirty="0"/>
           </a:p>

</xml_diff>